<commit_message>
Hero footage: women of color only; headquarters-only map slides
- Remove boxer and soccer clips; hero crossfades basketball (#6764724) and
  volleyball (#10350259), vertical versions on phones
- Hero video sits beside the headline at mid-size widths too
- Decks: competitor map slide now headquarters-only (no regional focus
  language); South Carolina unshaded so only HQ states are marked
- Brand guide, design system, and video credits updated; note on paid
  footage options for more women-of-color soccer/basketball

Co-Authored-By: Claude Opus 5.5 <noreply@anthropic.com>
</commit_message>
<xml_diff>
--- a/_strategy/Dexter_Sports_Overview_PUBLIC.pptx
+++ b/_strategy/Dexter_Sports_Overview_PUBLIC.pptx
@@ -4,6 +4,9 @@
   <p:sldMasterIdLst>
     <p:sldMasterId id="2147483648" r:id="rId1"/>
   </p:sldMasterIdLst>
+  <p:notesMasterIdLst>
+    <p:notesMasterId r:id="rId12"/>
+  </p:notesMasterIdLst>
   <p:sldIdLst>
     <p:sldId id="256" r:id="rId2"/>
     <p:sldId id="257" r:id="rId3"/>
@@ -16,9 +19,6 @@
     <p:sldId id="264" r:id="rId10"/>
     <p:sldId id="265" r:id="rId11"/>
   </p:sldIdLst>
-  <p:notesMasterIdLst>
-    <p:notesMasterId r:id="rId12"/>
-  </p:notesMasterIdLst>
   <p:sldSz cx="12192000" cy="6858000"/>
   <p:notesSz cx="6858000" cy="12192000"/>
   <p:defaultTextStyle>
@@ -113,6 +113,11 @@
       </a:defRPr>
     </a:lvl9pPr>
   </p:defaultTextStyle>
+  <p:extLst>
+    <p:ext uri="{EFAFB233-063F-42B5-8137-9DF3F51BA10A}">
+      <p15:sldGuideLst xmlns:p15="http://schemas.microsoft.com/office/powerpoint/2012/main"/>
+    </p:ext>
+  </p:extLst>
 </p:presentation>
 </file>
 
@@ -138,234 +143,10 @@
           <a:chExt cx="0" cy="0"/>
         </a:xfrm>
       </p:grpSpPr>
-      <p:sp>
-        <p:nvSpPr>
-          <p:cNvPr id="2" name="Header Placeholder 1"/>
-          <p:cNvSpPr>
-            <a:spLocks noGrp="1"/>
-          </p:cNvSpPr>
-          <p:nvPr>
-            <p:ph type="hdr" sz="quarter"/>
-          </p:nvPr>
-        </p:nvSpPr>
-        <p:spPr>
-          <a:xfrm>
-            <a:off x="0" y="0"/>
-            <a:ext cx="2971800" cy="458788"/>
-          </a:xfrm>
-          <a:prstGeom prst="rect">
-            <a:avLst/>
-          </a:prstGeom>
-        </p:spPr>
-        <p:txBody>
-          <a:bodyPr vert="horz" lIns="91440" tIns="45720" rIns="91440" bIns="45720" rtlCol="0"/>
-          <a:lstStyle>
-            <a:lvl1pPr algn="l">
-              <a:defRPr sz="1200"/>
-            </a:lvl1pPr>
-          </a:lstStyle>
-          <a:p>
-            <a:endParaRPr lang="en-US"/>
-          </a:p>
-        </p:txBody>
-      </p:sp>
-      <p:sp>
-        <p:nvSpPr>
-          <p:cNvPr id="3" name="Date Placeholder 2"/>
-          <p:cNvSpPr>
-            <a:spLocks noGrp="1"/>
-          </p:cNvSpPr>
-          <p:nvPr>
-            <p:ph type="dt" idx="1"/>
-          </p:nvPr>
-        </p:nvSpPr>
-        <p:spPr>
-          <a:xfrm>
-            <a:off x="3884613" y="0"/>
-            <a:ext cx="2971800" cy="458788"/>
-          </a:xfrm>
-          <a:prstGeom prst="rect">
-            <a:avLst/>
-          </a:prstGeom>
-        </p:spPr>
-        <p:txBody>
-          <a:bodyPr vert="horz" lIns="91440" tIns="45720" rIns="91440" bIns="45720" rtlCol="0"/>
-          <a:lstStyle>
-            <a:lvl1pPr algn="r">
-              <a:defRPr sz="1200"/>
-            </a:lvl1pPr>
-          </a:lstStyle>
-          <a:p>
-            <a:fld id="{5282F153-3F37-0F45-9E97-73ACFA13230C}" type="datetimeFigureOut">
-              <a:rPr lang="en-US"/>
-              <a:t>7/23/19</a:t>
-            </a:fld>
-            <a:endParaRPr lang="en-US"/>
-          </a:p>
-        </p:txBody>
-      </p:sp>
-      <p:sp>
-        <p:nvSpPr>
-          <p:cNvPr id="4" name="Slide Image Placeholder 3"/>
-          <p:cNvSpPr>
-            <a:spLocks noGrp="1" noRot="1" noChangeAspect="1"/>
-          </p:cNvSpPr>
-          <p:nvPr>
-            <p:ph type="sldImg" idx="2"/>
-          </p:nvPr>
-        </p:nvSpPr>
-        <p:spPr>
-          <a:xfrm>
-            <a:off x="685800" y="1143000"/>
-            <a:ext cx="5486400" cy="3086100"/>
-          </a:xfrm>
-          <a:prstGeom prst="rect">
-            <a:avLst/>
-          </a:prstGeom>
-          <a:noFill/>
-          <a:ln w="12700">
-            <a:solidFill>
-              <a:prstClr val="black"/>
-            </a:solidFill>
-          </a:ln>
-        </p:spPr>
-        <p:txBody>
-          <a:bodyPr vert="horz" lIns="91440" tIns="45720" rIns="91440" bIns="45720" rtlCol="0" anchor="ctr"/>
-          <a:lstStyle/>
-          <a:p>
-            <a:endParaRPr lang="en-US"/>
-          </a:p>
-        </p:txBody>
-      </p:sp>
-      <p:sp>
-        <p:nvSpPr>
-          <p:cNvPr id="5" name="Notes Placeholder 4"/>
-          <p:cNvSpPr>
-            <a:spLocks noGrp="1"/>
-          </p:cNvSpPr>
-          <p:nvPr>
-            <p:ph type="body" sz="quarter" idx="3"/>
-          </p:nvPr>
-        </p:nvSpPr>
-        <p:spPr>
-          <a:xfrm>
-            <a:off x="685800" y="4400550"/>
-            <a:ext cx="5486400" cy="3600450"/>
-          </a:xfrm>
-          <a:prstGeom prst="rect">
-            <a:avLst/>
-          </a:prstGeom>
-        </p:spPr>
-        <p:txBody>
-          <a:bodyPr vert="horz" lIns="91440" tIns="45720" rIns="91440" bIns="45720" rtlCol="0"/>
-          <a:lstStyle/>
-          <a:p>
-            <a:pPr lvl="0"/>
-            <a:r>
-              <a:rPr lang="en-US"/>
-              <a:t>Click to edit Master text styles</a:t>
-            </a:r>
-          </a:p>
-          <a:p>
-            <a:pPr lvl="1"/>
-            <a:r>
-              <a:rPr lang="en-US"/>
-              <a:t>Second level</a:t>
-            </a:r>
-          </a:p>
-          <a:p>
-            <a:pPr lvl="2"/>
-            <a:r>
-              <a:rPr lang="en-US"/>
-              <a:t>Third level</a:t>
-            </a:r>
-          </a:p>
-          <a:p>
-            <a:pPr lvl="3"/>
-            <a:r>
-              <a:rPr lang="en-US"/>
-              <a:t>Fourth level</a:t>
-            </a:r>
-          </a:p>
-          <a:p>
-            <a:pPr lvl="4"/>
-            <a:r>
-              <a:rPr lang="en-US"/>
-              <a:t>Fifth level</a:t>
-            </a:r>
-          </a:p>
-        </p:txBody>
-      </p:sp>
-      <p:sp>
-        <p:nvSpPr>
-          <p:cNvPr id="6" name="Footer Placeholder 5"/>
-          <p:cNvSpPr>
-            <a:spLocks noGrp="1"/>
-          </p:cNvSpPr>
-          <p:nvPr>
-            <p:ph type="ftr" sz="quarter" idx="4"/>
-          </p:nvPr>
-        </p:nvSpPr>
-        <p:spPr>
-          <a:xfrm>
-            <a:off x="0" y="8685213"/>
-            <a:ext cx="2971800" cy="458787"/>
-          </a:xfrm>
-          <a:prstGeom prst="rect">
-            <a:avLst/>
-          </a:prstGeom>
-        </p:spPr>
-        <p:txBody>
-          <a:bodyPr vert="horz" lIns="91440" tIns="45720" rIns="91440" bIns="45720" rtlCol="0" anchor="b"/>
-          <a:lstStyle>
-            <a:lvl1pPr algn="l">
-              <a:defRPr sz="1200"/>
-            </a:lvl1pPr>
-          </a:lstStyle>
-          <a:p>
-            <a:endParaRPr lang="en-US"/>
-          </a:p>
-        </p:txBody>
-      </p:sp>
-      <p:sp>
-        <p:nvSpPr>
-          <p:cNvPr id="7" name="Slide Number Placeholder 6"/>
-          <p:cNvSpPr>
-            <a:spLocks noGrp="1"/>
-          </p:cNvSpPr>
-          <p:nvPr>
-            <p:ph type="sldNum" sz="quarter" idx="5"/>
-          </p:nvPr>
-        </p:nvSpPr>
-        <p:spPr>
-          <a:xfrm>
-            <a:off x="3884613" y="8685213"/>
-            <a:ext cx="2971800" cy="458787"/>
-          </a:xfrm>
-          <a:prstGeom prst="rect">
-            <a:avLst/>
-          </a:prstGeom>
-        </p:spPr>
-        <p:txBody>
-          <a:bodyPr vert="horz" lIns="91440" tIns="45720" rIns="91440" bIns="45720" rtlCol="0" anchor="b"/>
-          <a:lstStyle>
-            <a:lvl1pPr algn="r">
-              <a:defRPr sz="1200"/>
-            </a:lvl1pPr>
-          </a:lstStyle>
-          <a:p>
-            <a:fld id="{CE5E9CC1-C706-0F49-92D6-E571CC5EEA8F}" type="slidenum">
-              <a:rPr lang="en-US"/>
-              <a:t>‹#›</a:t>
-            </a:fld>
-            <a:endParaRPr lang="en-US"/>
-          </a:p>
-        </p:txBody>
-      </p:sp>
     </p:spTree>
     <p:extLst>
       <p:ext uri="{BB962C8B-B14F-4D97-AF65-F5344CB8AC3E}">
-        <p14:creationId xmlns:p14="http://schemas.microsoft.com/office/powerpoint/2010/main" val="1024086991"/>
+        <p14:creationId xmlns:p14="http://schemas.microsoft.com/office/powerpoint/2010/main" val="243445145"/>
       </p:ext>
     </p:extLst>
   </p:cSld>
@@ -509,10 +290,6 @@
           <a:bodyPr/>
           <a:lstStyle/>
           <a:p>
-            <a:r>
-              <a:rPr lang="en-US" dirty="0"/>
-              <a:t/>
-            </a:r>
             <a:endParaRPr lang="en-US" dirty="0"/>
           </a:p>
         </p:txBody>
@@ -597,10 +374,6 @@
           <a:bodyPr/>
           <a:lstStyle/>
           <a:p>
-            <a:r>
-              <a:rPr lang="en-US" dirty="0"/>
-              <a:t/>
-            </a:r>
             <a:endParaRPr lang="en-US" dirty="0"/>
           </a:p>
         </p:txBody>
@@ -685,10 +458,6 @@
           <a:bodyPr/>
           <a:lstStyle/>
           <a:p>
-            <a:r>
-              <a:rPr lang="en-US" dirty="0"/>
-              <a:t/>
-            </a:r>
             <a:endParaRPr lang="en-US" dirty="0"/>
           </a:p>
         </p:txBody>
@@ -773,10 +542,6 @@
           <a:bodyPr/>
           <a:lstStyle/>
           <a:p>
-            <a:r>
-              <a:rPr lang="en-US" dirty="0"/>
-              <a:t/>
-            </a:r>
             <a:endParaRPr lang="en-US" dirty="0"/>
           </a:p>
         </p:txBody>
@@ -861,10 +626,6 @@
           <a:bodyPr/>
           <a:lstStyle/>
           <a:p>
-            <a:r>
-              <a:rPr lang="en-US" dirty="0"/>
-              <a:t/>
-            </a:r>
             <a:endParaRPr lang="en-US" dirty="0"/>
           </a:p>
         </p:txBody>
@@ -949,10 +710,6 @@
           <a:bodyPr/>
           <a:lstStyle/>
           <a:p>
-            <a:r>
-              <a:rPr lang="en-US" dirty="0"/>
-              <a:t/>
-            </a:r>
             <a:endParaRPr lang="en-US" dirty="0"/>
           </a:p>
         </p:txBody>
@@ -1037,10 +794,6 @@
           <a:bodyPr/>
           <a:lstStyle/>
           <a:p>
-            <a:r>
-              <a:rPr lang="en-US" dirty="0"/>
-              <a:t/>
-            </a:r>
             <a:endParaRPr lang="en-US" dirty="0"/>
           </a:p>
         </p:txBody>
@@ -1125,10 +878,6 @@
           <a:bodyPr/>
           <a:lstStyle/>
           <a:p>
-            <a:r>
-              <a:rPr lang="en-US" dirty="0"/>
-              <a:t/>
-            </a:r>
             <a:endParaRPr lang="en-US" dirty="0"/>
           </a:p>
         </p:txBody>
@@ -1213,10 +962,6 @@
           <a:bodyPr/>
           <a:lstStyle/>
           <a:p>
-            <a:r>
-              <a:rPr lang="en-US" dirty="0"/>
-              <a:t/>
-            </a:r>
             <a:endParaRPr lang="en-US" dirty="0"/>
           </a:p>
         </p:txBody>
@@ -1301,10 +1046,6 @@
           <a:bodyPr/>
           <a:lstStyle/>
           <a:p>
-            <a:r>
-              <a:rPr lang="en-US" dirty="0"/>
-              <a:t/>
-            </a:r>
             <a:endParaRPr lang="en-US" dirty="0"/>
           </a:p>
         </p:txBody>
@@ -1378,6 +1119,11 @@
 <file path=ppt/slideMasters/slideMaster1.xml><?xml version="1.0" encoding="utf-8"?>
 <p:sldMaster xmlns:a="http://schemas.openxmlformats.org/drawingml/2006/main" xmlns:r="http://schemas.openxmlformats.org/officeDocument/2006/relationships" xmlns:p="http://schemas.openxmlformats.org/presentationml/2006/main">
   <p:cSld>
+    <p:bg>
+      <p:bgRef idx="1001">
+        <a:schemeClr val="bg1"/>
+      </p:bgRef>
+    </p:bg>
     <p:spTree>
       <p:nvGrpSpPr>
         <p:cNvPr id="1" name=""/>
@@ -1660,6 +1406,7 @@
         <a:solidFill>
           <a:srgbClr val="0B1220"/>
         </a:solidFill>
+        <a:effectLst/>
       </p:bgPr>
     </p:bg>
     <p:spTree>
@@ -1697,7 +1444,7 @@
           <a:bodyPr wrap="square" rtlCol="0" anchor="ctr"/>
           <a:lstStyle/>
           <a:p>
-            <a:pPr algn="ctr" indent="0" marL="0">
+            <a:pPr marL="0" indent="0" algn="ctr">
               <a:buNone/>
             </a:pPr>
             <a:r>
@@ -1758,7 +1505,7 @@
           <a:bodyPr wrap="square" rtlCol="0" anchor="ctr"/>
           <a:lstStyle/>
           <a:p>
-            <a:pPr algn="ctr" indent="0" marL="0">
+            <a:pPr marL="0" indent="0" algn="ctr">
               <a:buNone/>
             </a:pPr>
             <a:r>
@@ -1797,7 +1544,7 @@
           <a:bodyPr wrap="square" rtlCol="0" anchor="ctr"/>
           <a:lstStyle/>
           <a:p>
-            <a:pPr indent="0" marL="0">
+            <a:pPr marL="0" indent="0">
               <a:buNone/>
             </a:pPr>
             <a:r>
@@ -1811,9 +1558,6 @@
               </a:rPr>
               <a:t>Dexter </a:t>
             </a:r>
-            <a:pPr indent="0" marL="0">
-              <a:buNone/>
-            </a:pPr>
             <a:r>
               <a:rPr lang="en-US" sz="1300" i="1" dirty="0">
                 <a:solidFill>
@@ -1850,7 +1594,7 @@
           <a:bodyPr wrap="square" rtlCol="0" anchor="ctr"/>
           <a:lstStyle/>
           <a:p>
-            <a:pPr indent="0" marL="0">
+            <a:pPr marL="0" indent="0">
               <a:buNone/>
             </a:pPr>
             <a:r>
@@ -1864,11 +1608,8 @@
               </a:rPr>
               <a:t>● </a:t>
             </a:r>
-            <a:pPr indent="0" marL="0">
-              <a:buNone/>
-            </a:pPr>
-            <a:r>
-              <a:rPr lang="en-US" sz="1200" b="1" spc="200" kern="0" dirty="0">
+            <a:r>
+              <a:rPr lang="en-US" sz="1200" b="1" kern="0" spc="200" dirty="0">
                 <a:solidFill>
                   <a:srgbClr val="93B4FF"/>
                 </a:solidFill>
@@ -1878,9 +1619,6 @@
               </a:rPr>
               <a:t>COACH REPRESENTATION</a:t>
             </a:r>
-            <a:pPr indent="0" marL="0">
-              <a:buNone/>
-            </a:pPr>
             <a:r>
               <a:rPr lang="en-US" sz="1200" dirty="0">
                 <a:solidFill>
@@ -1892,11 +1630,8 @@
               </a:rPr>
               <a:t>   ·   </a:t>
             </a:r>
-            <a:pPr indent="0" marL="0">
-              <a:buNone/>
-            </a:pPr>
-            <a:r>
-              <a:rPr lang="en-US" sz="1200" b="1" spc="200" kern="0" dirty="0">
+            <a:r>
+              <a:rPr lang="en-US" sz="1200" b="1" kern="0" spc="200" dirty="0">
                 <a:solidFill>
                   <a:srgbClr val="93B4FF"/>
                 </a:solidFill>
@@ -1931,7 +1666,7 @@
           <a:bodyPr wrap="square" rtlCol="0" anchor="ctr"/>
           <a:lstStyle/>
           <a:p>
-            <a:pPr indent="0" marL="0">
+            <a:pPr marL="0" indent="0">
               <a:lnSpc>
                 <a:spcPct val="102000"/>
               </a:lnSpc>
@@ -1947,32 +1682,9 @@
                 <a:cs typeface="Arial" pitchFamily="34" charset="-120"/>
               </a:rPr>
               <a:t>Protect the talent.
+Shape the opportunity.
 </a:t>
             </a:r>
-            <a:pPr indent="0" marL="0">
-              <a:lnSpc>
-                <a:spcPct val="102000"/>
-              </a:lnSpc>
-              <a:buNone/>
-            </a:pPr>
-            <a:r>
-              <a:rPr lang="en-US" sz="4600" b="1" dirty="0">
-                <a:solidFill>
-                  <a:srgbClr val="FFFFFF"/>
-                </a:solidFill>
-                <a:latin typeface="Arial" pitchFamily="34" charset="0"/>
-                <a:ea typeface="Arial" pitchFamily="34" charset="-122"/>
-                <a:cs typeface="Arial" pitchFamily="34" charset="-120"/>
-              </a:rPr>
-              <a:t>Shape the opportunity.
-</a:t>
-            </a:r>
-            <a:pPr indent="0" marL="0">
-              <a:lnSpc>
-                <a:spcPct val="102000"/>
-              </a:lnSpc>
-              <a:buNone/>
-            </a:pPr>
             <a:r>
               <a:rPr lang="en-US" sz="4600" i="1" dirty="0">
                 <a:solidFill>
@@ -2009,7 +1721,7 @@
           <a:bodyPr wrap="square" rtlCol="0" anchor="ctr"/>
           <a:lstStyle/>
           <a:p>
-            <a:pPr indent="0" marL="0">
+            <a:pPr marL="0" indent="0">
               <a:lnSpc>
                 <a:spcPct val="120000"/>
               </a:lnSpc>
@@ -2051,11 +1763,11 @@
           <a:bodyPr wrap="square" rtlCol="0" anchor="ctr"/>
           <a:lstStyle/>
           <a:p>
-            <a:pPr indent="0" marL="0">
-              <a:buNone/>
-            </a:pPr>
-            <a:r>
-              <a:rPr lang="en-US" sz="1050" b="1" spc="200" kern="0" dirty="0">
+            <a:pPr marL="0" indent="0">
+              <a:buNone/>
+            </a:pPr>
+            <a:r>
+              <a:rPr lang="en-US" sz="1050" b="1" kern="0" spc="200" dirty="0">
                 <a:solidFill>
                   <a:srgbClr val="FFFFFF"/>
                 </a:solidFill>
@@ -2090,7 +1802,7 @@
           <a:bodyPr wrap="square" rtlCol="0" anchor="ctr"/>
           <a:lstStyle/>
           <a:p>
-            <a:pPr indent="0" marL="0">
+            <a:pPr marL="0" indent="0">
               <a:buNone/>
             </a:pPr>
             <a:r>
@@ -2124,6 +1836,7 @@
         <a:solidFill>
           <a:srgbClr val="0B1220"/>
         </a:solidFill>
+        <a:effectLst/>
       </p:bgPr>
     </p:bg>
     <p:spTree>
@@ -2161,7 +1874,7 @@
           <a:bodyPr wrap="square" rtlCol="0" anchor="ctr"/>
           <a:lstStyle/>
           <a:p>
-            <a:pPr algn="ctr" indent="0" marL="0">
+            <a:pPr marL="0" indent="0" algn="ctr">
               <a:buNone/>
             </a:pPr>
             <a:r>
@@ -2222,7 +1935,7 @@
           <a:bodyPr wrap="square" rtlCol="0" anchor="ctr"/>
           <a:lstStyle/>
           <a:p>
-            <a:pPr algn="ctr" indent="0" marL="0">
+            <a:pPr marL="0" indent="0" algn="ctr">
               <a:buNone/>
             </a:pPr>
             <a:r>
@@ -2261,7 +1974,7 @@
           <a:bodyPr wrap="square" rtlCol="0" anchor="ctr"/>
           <a:lstStyle/>
           <a:p>
-            <a:pPr indent="0" marL="0">
+            <a:pPr marL="0" indent="0">
               <a:buNone/>
             </a:pPr>
             <a:r>
@@ -2275,9 +1988,6 @@
               </a:rPr>
               <a:t>Dexter </a:t>
             </a:r>
-            <a:pPr indent="0" marL="0">
-              <a:buNone/>
-            </a:pPr>
             <a:r>
               <a:rPr lang="en-US" sz="1300" i="1" dirty="0">
                 <a:solidFill>
@@ -2314,7 +2024,7 @@
           <a:bodyPr wrap="square" rtlCol="0" anchor="ctr"/>
           <a:lstStyle/>
           <a:p>
-            <a:pPr indent="0" marL="0">
+            <a:pPr marL="0" indent="0">
               <a:lnSpc>
                 <a:spcPct val="105000"/>
               </a:lnSpc>
@@ -2331,12 +2041,6 @@
               </a:rPr>
               <a:t>Protect the talent. </a:t>
             </a:r>
-            <a:pPr indent="0" marL="0">
-              <a:lnSpc>
-                <a:spcPct val="105000"/>
-              </a:lnSpc>
-              <a:buNone/>
-            </a:pPr>
             <a:r>
               <a:rPr lang="en-US" sz="3400" i="1" dirty="0">
                 <a:solidFill>
@@ -2373,7 +2077,7 @@
           <a:bodyPr wrap="square" rtlCol="0" anchor="ctr"/>
           <a:lstStyle/>
           <a:p>
-            <a:pPr indent="0" marL="0">
+            <a:pPr marL="0" indent="0">
               <a:lnSpc>
                 <a:spcPct val="120000"/>
               </a:lnSpc>
@@ -2396,14 +2100,14 @@
       </p:sp>
       <p:pic>
         <p:nvPicPr>
-          <p:cNvPr id="8" name="Image 0" descr="preencoded.png">    </p:cNvPr>
+          <p:cNvPr id="8" name="Image 0" descr="preencoded.png"/>
           <p:cNvPicPr>
             <a:picLocks noChangeAspect="1"/>
           </p:cNvPicPr>
           <p:nvPr/>
         </p:nvPicPr>
         <p:blipFill>
-          <a:blip r:embed="rId1"/>
+          <a:blip r:embed="rId3"/>
           <a:stretch>
             <a:fillRect/>
           </a:stretch>
@@ -2439,7 +2143,7 @@
           <a:bodyPr wrap="square" rtlCol="0" anchor="ctr"/>
           <a:lstStyle/>
           <a:p>
-            <a:pPr indent="0" marL="0">
+            <a:pPr marL="0" indent="0">
               <a:buNone/>
             </a:pPr>
             <a:r>
@@ -2459,14 +2163,14 @@
       </p:sp>
       <p:pic>
         <p:nvPicPr>
-          <p:cNvPr id="10" name="Image 1" descr="preencoded.png">    </p:cNvPr>
+          <p:cNvPr id="10" name="Image 1" descr="preencoded.png"/>
           <p:cNvPicPr>
             <a:picLocks noChangeAspect="1"/>
           </p:cNvPicPr>
           <p:nvPr/>
         </p:nvPicPr>
         <p:blipFill>
-          <a:blip r:embed="rId2"/>
+          <a:blip r:embed="rId4"/>
           <a:stretch>
             <a:fillRect/>
           </a:stretch>
@@ -2502,7 +2206,7 @@
           <a:bodyPr wrap="square" rtlCol="0" anchor="ctr"/>
           <a:lstStyle/>
           <a:p>
-            <a:pPr indent="0" marL="0">
+            <a:pPr marL="0" indent="0">
               <a:buNone/>
             </a:pPr>
             <a:r>
@@ -2536,6 +2240,7 @@
         <a:solidFill>
           <a:srgbClr val="FFFFFF"/>
         </a:solidFill>
+        <a:effectLst/>
       </p:bgPr>
     </p:bg>
     <p:spTree>
@@ -2573,7 +2278,7 @@
           <a:bodyPr wrap="square" rtlCol="0" anchor="ctr"/>
           <a:lstStyle/>
           <a:p>
-            <a:pPr indent="0" marL="0">
+            <a:pPr marL="0" indent="0">
               <a:buNone/>
             </a:pPr>
             <a:r>
@@ -2587,11 +2292,8 @@
               </a:rPr>
               <a:t>● </a:t>
             </a:r>
-            <a:pPr indent="0" marL="0">
-              <a:buNone/>
-            </a:pPr>
-            <a:r>
-              <a:rPr lang="en-US" sz="1100" b="1" spc="300" kern="0" dirty="0">
+            <a:r>
+              <a:rPr lang="en-US" sz="1100" b="1" kern="0" spc="300" dirty="0">
                 <a:solidFill>
                   <a:srgbClr val="2563EB"/>
                 </a:solidFill>
@@ -2626,7 +2328,7 @@
           <a:bodyPr wrap="square" rtlCol="0" anchor="ctr"/>
           <a:lstStyle/>
           <a:p>
-            <a:pPr indent="0" marL="0">
+            <a:pPr marL="0" indent="0">
               <a:buNone/>
             </a:pPr>
             <a:r>
@@ -2640,9 +2342,6 @@
               </a:rPr>
               <a:t>The coaches the big agencies </a:t>
             </a:r>
-            <a:pPr indent="0" marL="0">
-              <a:buNone/>
-            </a:pPr>
             <a:r>
               <a:rPr lang="en-US" sz="2900" i="1" dirty="0">
                 <a:solidFill>
@@ -2682,273 +2381,7 @@
       </p:sp>
       <p:pic>
         <p:nvPicPr>
-          <p:cNvPr id="5" name="Image 0" descr="preencoded.png">    </p:cNvPr>
-          <p:cNvPicPr>
-            <a:picLocks noChangeAspect="1"/>
-          </p:cNvPicPr>
-          <p:nvPr/>
-        </p:nvPicPr>
-        <p:blipFill>
-          <a:blip r:embed="rId1"/>
-          <a:stretch>
-            <a:fillRect/>
-          </a:stretch>
-        </p:blipFill>
-        <p:spPr>
-          <a:xfrm>
-            <a:off x="1051560" y="2331720"/>
-            <a:ext cx="548640" cy="548640"/>
-          </a:xfrm>
-          <a:prstGeom prst="rect">
-            <a:avLst/>
-          </a:prstGeom>
-        </p:spPr>
-      </p:pic>
-      <p:sp>
-        <p:nvSpPr>
-          <p:cNvPr id="6" name="Text 3"/>
-          <p:cNvSpPr/>
-          <p:nvPr/>
-        </p:nvSpPr>
-        <p:spPr>
-          <a:xfrm>
-            <a:off x="1005840" y="3063240"/>
-            <a:ext cx="3108960" cy="731520"/>
-          </a:xfrm>
-          <a:prstGeom prst="rect">
-            <a:avLst/>
-          </a:prstGeom>
-          <a:noFill/>
-          <a:ln/>
-        </p:spPr>
-        <p:txBody>
-          <a:bodyPr wrap="square" rtlCol="0" anchor="ctr"/>
-          <a:lstStyle/>
-          <a:p>
-            <a:pPr indent="0" marL="0">
-              <a:buNone/>
-            </a:pPr>
-            <a:r>
-              <a:rPr lang="en-US" sz="3300" b="1" dirty="0">
-                <a:solidFill>
-                  <a:srgbClr val="FFFFFF"/>
-                </a:solidFill>
-                <a:latin typeface="Arial" pitchFamily="34" charset="0"/>
-                <a:ea typeface="Arial" pitchFamily="34" charset="-122"/>
-                <a:cs typeface="Arial" pitchFamily="34" charset="-120"/>
-              </a:rPr>
-              <a:t>$500K–$5M+</a:t>
-            </a:r>
-            <a:endParaRPr lang="en-US" sz="3300" dirty="0"/>
-          </a:p>
-        </p:txBody>
-      </p:sp>
-      <p:sp>
-        <p:nvSpPr>
-          <p:cNvPr id="7" name="Text 4"/>
-          <p:cNvSpPr/>
-          <p:nvPr/>
-        </p:nvSpPr>
-        <p:spPr>
-          <a:xfrm>
-            <a:off x="1005840" y="3840480"/>
-            <a:ext cx="3017520" cy="731520"/>
-          </a:xfrm>
-          <a:prstGeom prst="rect">
-            <a:avLst/>
-          </a:prstGeom>
-          <a:noFill/>
-          <a:ln/>
-        </p:spPr>
-        <p:txBody>
-          <a:bodyPr wrap="square" rtlCol="0" anchor="t"/>
-          <a:lstStyle/>
-          <a:p>
-            <a:pPr indent="0" marL="0">
-              <a:buNone/>
-            </a:pPr>
-            <a:r>
-              <a:rPr lang="en-US" sz="1300" dirty="0">
-                <a:solidFill>
-                  <a:srgbClr val="93B4FF"/>
-                </a:solidFill>
-                <a:latin typeface="Arial" pitchFamily="34" charset="0"/>
-                <a:ea typeface="Arial" pitchFamily="34" charset="-122"/>
-                <a:cs typeface="Arial" pitchFamily="34" charset="-120"/>
-              </a:rPr>
-              <a:t>Typical collegiate head-coaching salary range.</a:t>
-            </a:r>
-            <a:endParaRPr lang="en-US" sz="1300" dirty="0"/>
-          </a:p>
-        </p:txBody>
-      </p:sp>
-      <p:sp>
-        <p:nvSpPr>
-          <p:cNvPr id="8" name="Text 5"/>
-          <p:cNvSpPr/>
-          <p:nvPr/>
-        </p:nvSpPr>
-        <p:spPr>
-          <a:xfrm>
-            <a:off x="1005840" y="4892040"/>
-            <a:ext cx="3017520" cy="914400"/>
-          </a:xfrm>
-          <a:prstGeom prst="rect">
-            <a:avLst/>
-          </a:prstGeom>
-          <a:noFill/>
-          <a:ln/>
-        </p:spPr>
-        <p:txBody>
-          <a:bodyPr wrap="square" rtlCol="0" anchor="t"/>
-          <a:lstStyle/>
-          <a:p>
-            <a:pPr indent="0" marL="0">
-              <a:buNone/>
-            </a:pPr>
-            <a:r>
-              <a:rPr lang="en-US" sz="1250" i="1" dirty="0">
-                <a:solidFill>
-                  <a:srgbClr val="D4A62A"/>
-                </a:solidFill>
-                <a:latin typeface="Georgia" pitchFamily="34" charset="0"/>
-                <a:ea typeface="Georgia" pitchFamily="34" charset="-122"/>
-                <a:cs typeface="Georgia" pitchFamily="34" charset="-120"/>
-              </a:rPr>
-              <a:t>A market where one placed coach can change a career — and a program.</a:t>
-            </a:r>
-            <a:endParaRPr lang="en-US" sz="1250" dirty="0"/>
-          </a:p>
-        </p:txBody>
-      </p:sp>
-      <p:pic>
-        <p:nvPicPr>
-          <p:cNvPr id="9" name="Image 1" descr="preencoded.png">    </p:cNvPr>
-          <p:cNvPicPr>
-            <a:picLocks noChangeAspect="1"/>
-          </p:cNvPicPr>
-          <p:nvPr/>
-        </p:nvPicPr>
-        <p:blipFill>
-          <a:blip r:embed="rId2"/>
-          <a:stretch>
-            <a:fillRect/>
-          </a:stretch>
-        </p:blipFill>
-        <p:spPr>
-          <a:xfrm>
-            <a:off x="4709160" y="2011680"/>
-            <a:ext cx="475488" cy="475488"/>
-          </a:xfrm>
-          <a:prstGeom prst="rect">
-            <a:avLst/>
-          </a:prstGeom>
-        </p:spPr>
-      </p:pic>
-      <p:sp>
-        <p:nvSpPr>
-          <p:cNvPr id="10" name="Text 6"/>
-          <p:cNvSpPr/>
-          <p:nvPr/>
-        </p:nvSpPr>
-        <p:spPr>
-          <a:xfrm>
-            <a:off x="5440680" y="1947672"/>
-            <a:ext cx="6035040" cy="411480"/>
-          </a:xfrm>
-          <a:prstGeom prst="rect">
-            <a:avLst/>
-          </a:prstGeom>
-          <a:noFill/>
-          <a:ln/>
-        </p:spPr>
-        <p:txBody>
-          <a:bodyPr wrap="square" rtlCol="0" anchor="ctr"/>
-          <a:lstStyle/>
-          <a:p>
-            <a:pPr indent="0" marL="0">
-              <a:buNone/>
-            </a:pPr>
-            <a:r>
-              <a:rPr lang="en-US" sz="1650" b="1" dirty="0">
-                <a:solidFill>
-                  <a:srgbClr val="141A24"/>
-                </a:solidFill>
-                <a:latin typeface="Arial" pitchFamily="34" charset="0"/>
-                <a:ea typeface="Arial" pitchFamily="34" charset="-122"/>
-                <a:cs typeface="Arial" pitchFamily="34" charset="-120"/>
-              </a:rPr>
-              <a:t>Female coaches are underrepresented</a:t>
-            </a:r>
-            <a:endParaRPr lang="en-US" sz="1650" dirty="0"/>
-          </a:p>
-        </p:txBody>
-      </p:sp>
-      <p:sp>
-        <p:nvSpPr>
-          <p:cNvPr id="11" name="Text 7"/>
-          <p:cNvSpPr/>
-          <p:nvPr/>
-        </p:nvSpPr>
-        <p:spPr>
-          <a:xfrm>
-            <a:off x="5440680" y="2377440"/>
-            <a:ext cx="5989320" cy="822960"/>
-          </a:xfrm>
-          <a:prstGeom prst="rect">
-            <a:avLst/>
-          </a:prstGeom>
-          <a:noFill/>
-          <a:ln/>
-        </p:spPr>
-        <p:txBody>
-          <a:bodyPr wrap="square" rtlCol="0" anchor="t"/>
-          <a:lstStyle/>
-          <a:p>
-            <a:pPr indent="0" marL="0">
-              <a:buNone/>
-            </a:pPr>
-            <a:r>
-              <a:rPr lang="en-US" sz="1200" dirty="0">
-                <a:solidFill>
-                  <a:srgbClr val="141A24"/>
-                </a:solidFill>
-                <a:latin typeface="Arial" pitchFamily="34" charset="0"/>
-                <a:ea typeface="Arial" pitchFamily="34" charset="-122"/>
-                <a:cs typeface="Arial" pitchFamily="34" charset="-120"/>
-              </a:rPr>
-              <a:t>Women fill the assistant pipeline but rarely reach the top jobs. Dedicated, outcomes-focused representation is scarce.</a:t>
-            </a:r>
-            <a:endParaRPr lang="en-US" sz="1200" dirty="0"/>
-          </a:p>
-        </p:txBody>
-      </p:sp>
-      <p:sp>
-        <p:nvSpPr>
-          <p:cNvPr id="12" name="Shape 8"/>
-          <p:cNvSpPr/>
-          <p:nvPr/>
-        </p:nvSpPr>
-        <p:spPr>
-          <a:xfrm>
-            <a:off x="4709160" y="3172968"/>
-            <a:ext cx="6766560" cy="0"/>
-          </a:xfrm>
-          <a:prstGeom prst="line">
-            <a:avLst/>
-          </a:prstGeom>
-          <a:noFill/>
-          <a:ln w="12700">
-            <a:solidFill>
-              <a:srgbClr val="E4E7EC"/>
-            </a:solidFill>
-            <a:prstDash val="solid"/>
-          </a:ln>
-        </p:spPr>
-      </p:sp>
-      <p:pic>
-        <p:nvPicPr>
-          <p:cNvPr id="13" name="Image 2" descr="preencoded.png">    </p:cNvPr>
+          <p:cNvPr id="5" name="Image 0" descr="preencoded.png"/>
           <p:cNvPicPr>
             <a:picLocks noChangeAspect="1"/>
           </p:cNvPicPr>
@@ -2962,8 +2395,8 @@
         </p:blipFill>
         <p:spPr>
           <a:xfrm>
-            <a:off x="4709160" y="3383280"/>
-            <a:ext cx="475488" cy="475488"/>
+            <a:off x="1051560" y="2331720"/>
+            <a:ext cx="548640" cy="548640"/>
           </a:xfrm>
           <a:prstGeom prst="rect">
             <a:avLst/>
@@ -2972,14 +2405,14 @@
       </p:pic>
       <p:sp>
         <p:nvSpPr>
-          <p:cNvPr id="14" name="Text 9"/>
-          <p:cNvSpPr/>
-          <p:nvPr/>
-        </p:nvSpPr>
-        <p:spPr>
-          <a:xfrm>
-            <a:off x="5440680" y="3319272"/>
-            <a:ext cx="6035040" cy="411480"/>
+          <p:cNvPr id="6" name="Text 3"/>
+          <p:cNvSpPr/>
+          <p:nvPr/>
+        </p:nvSpPr>
+        <p:spPr>
+          <a:xfrm>
+            <a:off x="1005840" y="3063240"/>
+            <a:ext cx="3108960" cy="731520"/>
           </a:xfrm>
           <a:prstGeom prst="rect">
             <a:avLst/>
@@ -2991,34 +2424,34 @@
           <a:bodyPr wrap="square" rtlCol="0" anchor="ctr"/>
           <a:lstStyle/>
           <a:p>
-            <a:pPr indent="0" marL="0">
-              <a:buNone/>
-            </a:pPr>
-            <a:r>
-              <a:rPr lang="en-US" sz="1650" b="1" dirty="0">
-                <a:solidFill>
-                  <a:srgbClr val="141A24"/>
-                </a:solidFill>
-                <a:latin typeface="Arial" pitchFamily="34" charset="0"/>
-                <a:ea typeface="Arial" pitchFamily="34" charset="-122"/>
-                <a:cs typeface="Arial" pitchFamily="34" charset="-120"/>
-              </a:rPr>
-              <a:t>NIL has reached high school</a:t>
-            </a:r>
-            <a:endParaRPr lang="en-US" sz="1650" dirty="0"/>
-          </a:p>
-        </p:txBody>
-      </p:sp>
-      <p:sp>
-        <p:nvSpPr>
-          <p:cNvPr id="15" name="Text 10"/>
-          <p:cNvSpPr/>
-          <p:nvPr/>
-        </p:nvSpPr>
-        <p:spPr>
-          <a:xfrm>
-            <a:off x="5440680" y="3749040"/>
-            <a:ext cx="5989320" cy="822960"/>
+            <a:pPr marL="0" indent="0">
+              <a:buNone/>
+            </a:pPr>
+            <a:r>
+              <a:rPr lang="en-US" sz="3300" b="1" dirty="0">
+                <a:solidFill>
+                  <a:srgbClr val="FFFFFF"/>
+                </a:solidFill>
+                <a:latin typeface="Arial" pitchFamily="34" charset="0"/>
+                <a:ea typeface="Arial" pitchFamily="34" charset="-122"/>
+                <a:cs typeface="Arial" pitchFamily="34" charset="-120"/>
+              </a:rPr>
+              <a:t>$500K–$5M+</a:t>
+            </a:r>
+            <a:endParaRPr lang="en-US" sz="3300" dirty="0"/>
+          </a:p>
+        </p:txBody>
+      </p:sp>
+      <p:sp>
+        <p:nvSpPr>
+          <p:cNvPr id="7" name="Text 4"/>
+          <p:cNvSpPr/>
+          <p:nvPr/>
+        </p:nvSpPr>
+        <p:spPr>
+          <a:xfrm>
+            <a:off x="1005840" y="3840480"/>
+            <a:ext cx="3017520" cy="731520"/>
           </a:xfrm>
           <a:prstGeom prst="rect">
             <a:avLst/>
@@ -3030,50 +2463,66 @@
           <a:bodyPr wrap="square" rtlCol="0" anchor="t"/>
           <a:lstStyle/>
           <a:p>
-            <a:pPr indent="0" marL="0">
-              <a:buNone/>
-            </a:pPr>
-            <a:r>
-              <a:rPr lang="en-US" sz="1200" dirty="0">
-                <a:solidFill>
-                  <a:srgbClr val="141A24"/>
-                </a:solidFill>
-                <a:latin typeface="Arial" pitchFamily="34" charset="0"/>
-                <a:ea typeface="Arial" pitchFamily="34" charset="-122"/>
-                <a:cs typeface="Arial" pitchFamily="34" charset="-120"/>
-              </a:rPr>
-              <a:t>North and South Carolina now permit HS NIL — a first-mover market for athletes and families navigating offers.</a:t>
-            </a:r>
-            <a:endParaRPr lang="en-US" sz="1200" dirty="0"/>
-          </a:p>
-        </p:txBody>
-      </p:sp>
-      <p:sp>
-        <p:nvSpPr>
-          <p:cNvPr id="16" name="Shape 11"/>
-          <p:cNvSpPr/>
-          <p:nvPr/>
-        </p:nvSpPr>
-        <p:spPr>
-          <a:xfrm>
-            <a:off x="4709160" y="4544568"/>
-            <a:ext cx="6766560" cy="0"/>
-          </a:xfrm>
-          <a:prstGeom prst="line">
-            <a:avLst/>
-          </a:prstGeom>
-          <a:noFill/>
-          <a:ln w="12700">
-            <a:solidFill>
-              <a:srgbClr val="E4E7EC"/>
-            </a:solidFill>
-            <a:prstDash val="solid"/>
-          </a:ln>
-        </p:spPr>
+            <a:pPr marL="0" indent="0">
+              <a:buNone/>
+            </a:pPr>
+            <a:r>
+              <a:rPr lang="en-US" sz="1300" dirty="0">
+                <a:solidFill>
+                  <a:srgbClr val="93B4FF"/>
+                </a:solidFill>
+                <a:latin typeface="Arial" pitchFamily="34" charset="0"/>
+                <a:ea typeface="Arial" pitchFamily="34" charset="-122"/>
+                <a:cs typeface="Arial" pitchFamily="34" charset="-120"/>
+              </a:rPr>
+              <a:t>Typical collegiate head-coaching salary range.</a:t>
+            </a:r>
+            <a:endParaRPr lang="en-US" sz="1300" dirty="0"/>
+          </a:p>
+        </p:txBody>
+      </p:sp>
+      <p:sp>
+        <p:nvSpPr>
+          <p:cNvPr id="8" name="Text 5"/>
+          <p:cNvSpPr/>
+          <p:nvPr/>
+        </p:nvSpPr>
+        <p:spPr>
+          <a:xfrm>
+            <a:off x="1005840" y="4892040"/>
+            <a:ext cx="3017520" cy="914400"/>
+          </a:xfrm>
+          <a:prstGeom prst="rect">
+            <a:avLst/>
+          </a:prstGeom>
+          <a:noFill/>
+          <a:ln/>
+        </p:spPr>
+        <p:txBody>
+          <a:bodyPr wrap="square" rtlCol="0" anchor="t"/>
+          <a:lstStyle/>
+          <a:p>
+            <a:pPr marL="0" indent="0">
+              <a:buNone/>
+            </a:pPr>
+            <a:r>
+              <a:rPr lang="en-US" sz="1250" i="1" dirty="0">
+                <a:solidFill>
+                  <a:srgbClr val="D4A62A"/>
+                </a:solidFill>
+                <a:latin typeface="Georgia" pitchFamily="34" charset="0"/>
+                <a:ea typeface="Georgia" pitchFamily="34" charset="-122"/>
+                <a:cs typeface="Georgia" pitchFamily="34" charset="-120"/>
+              </a:rPr>
+              <a:t>A market where one placed coach can change a career — and a program.</a:t>
+            </a:r>
+            <a:endParaRPr lang="en-US" sz="1250" dirty="0"/>
+          </a:p>
+        </p:txBody>
       </p:sp>
       <p:pic>
         <p:nvPicPr>
-          <p:cNvPr id="17" name="Image 3" descr="preencoded.png">    </p:cNvPr>
+          <p:cNvPr id="9" name="Image 1" descr="preencoded.png"/>
           <p:cNvPicPr>
             <a:picLocks noChangeAspect="1"/>
           </p:cNvPicPr>
@@ -3087,6 +2536,256 @@
         </p:blipFill>
         <p:spPr>
           <a:xfrm>
+            <a:off x="4709160" y="2011680"/>
+            <a:ext cx="475488" cy="475488"/>
+          </a:xfrm>
+          <a:prstGeom prst="rect">
+            <a:avLst/>
+          </a:prstGeom>
+        </p:spPr>
+      </p:pic>
+      <p:sp>
+        <p:nvSpPr>
+          <p:cNvPr id="10" name="Text 6"/>
+          <p:cNvSpPr/>
+          <p:nvPr/>
+        </p:nvSpPr>
+        <p:spPr>
+          <a:xfrm>
+            <a:off x="5440680" y="1947672"/>
+            <a:ext cx="6035040" cy="411480"/>
+          </a:xfrm>
+          <a:prstGeom prst="rect">
+            <a:avLst/>
+          </a:prstGeom>
+          <a:noFill/>
+          <a:ln/>
+        </p:spPr>
+        <p:txBody>
+          <a:bodyPr wrap="square" rtlCol="0" anchor="ctr"/>
+          <a:lstStyle/>
+          <a:p>
+            <a:pPr marL="0" indent="0">
+              <a:buNone/>
+            </a:pPr>
+            <a:r>
+              <a:rPr lang="en-US" sz="1650" b="1" dirty="0">
+                <a:solidFill>
+                  <a:srgbClr val="141A24"/>
+                </a:solidFill>
+                <a:latin typeface="Arial" pitchFamily="34" charset="0"/>
+                <a:ea typeface="Arial" pitchFamily="34" charset="-122"/>
+                <a:cs typeface="Arial" pitchFamily="34" charset="-120"/>
+              </a:rPr>
+              <a:t>Female coaches are underrepresented</a:t>
+            </a:r>
+            <a:endParaRPr lang="en-US" sz="1650" dirty="0"/>
+          </a:p>
+        </p:txBody>
+      </p:sp>
+      <p:sp>
+        <p:nvSpPr>
+          <p:cNvPr id="11" name="Text 7"/>
+          <p:cNvSpPr/>
+          <p:nvPr/>
+        </p:nvSpPr>
+        <p:spPr>
+          <a:xfrm>
+            <a:off x="5440680" y="2377440"/>
+            <a:ext cx="5989320" cy="822960"/>
+          </a:xfrm>
+          <a:prstGeom prst="rect">
+            <a:avLst/>
+          </a:prstGeom>
+          <a:noFill/>
+          <a:ln/>
+        </p:spPr>
+        <p:txBody>
+          <a:bodyPr wrap="square" rtlCol="0" anchor="t"/>
+          <a:lstStyle/>
+          <a:p>
+            <a:pPr marL="0" indent="0">
+              <a:buNone/>
+            </a:pPr>
+            <a:r>
+              <a:rPr lang="en-US" sz="1200" dirty="0">
+                <a:solidFill>
+                  <a:srgbClr val="141A24"/>
+                </a:solidFill>
+                <a:latin typeface="Arial" pitchFamily="34" charset="0"/>
+                <a:ea typeface="Arial" pitchFamily="34" charset="-122"/>
+                <a:cs typeface="Arial" pitchFamily="34" charset="-120"/>
+              </a:rPr>
+              <a:t>Women fill the assistant pipeline but rarely reach the top jobs. Dedicated, outcomes-focused representation is scarce.</a:t>
+            </a:r>
+            <a:endParaRPr lang="en-US" sz="1200" dirty="0"/>
+          </a:p>
+        </p:txBody>
+      </p:sp>
+      <p:sp>
+        <p:nvSpPr>
+          <p:cNvPr id="12" name="Shape 8"/>
+          <p:cNvSpPr/>
+          <p:nvPr/>
+        </p:nvSpPr>
+        <p:spPr>
+          <a:xfrm>
+            <a:off x="4709160" y="3172968"/>
+            <a:ext cx="6766560" cy="0"/>
+          </a:xfrm>
+          <a:prstGeom prst="line">
+            <a:avLst/>
+          </a:prstGeom>
+          <a:noFill/>
+          <a:ln w="12700">
+            <a:solidFill>
+              <a:srgbClr val="E4E7EC"/>
+            </a:solidFill>
+            <a:prstDash val="solid"/>
+          </a:ln>
+        </p:spPr>
+      </p:sp>
+      <p:pic>
+        <p:nvPicPr>
+          <p:cNvPr id="13" name="Image 2" descr="preencoded.png"/>
+          <p:cNvPicPr>
+            <a:picLocks noChangeAspect="1"/>
+          </p:cNvPicPr>
+          <p:nvPr/>
+        </p:nvPicPr>
+        <p:blipFill>
+          <a:blip r:embed="rId5"/>
+          <a:stretch>
+            <a:fillRect/>
+          </a:stretch>
+        </p:blipFill>
+        <p:spPr>
+          <a:xfrm>
+            <a:off x="4709160" y="3383280"/>
+            <a:ext cx="475488" cy="475488"/>
+          </a:xfrm>
+          <a:prstGeom prst="rect">
+            <a:avLst/>
+          </a:prstGeom>
+        </p:spPr>
+      </p:pic>
+      <p:sp>
+        <p:nvSpPr>
+          <p:cNvPr id="14" name="Text 9"/>
+          <p:cNvSpPr/>
+          <p:nvPr/>
+        </p:nvSpPr>
+        <p:spPr>
+          <a:xfrm>
+            <a:off x="5440680" y="3319272"/>
+            <a:ext cx="6035040" cy="411480"/>
+          </a:xfrm>
+          <a:prstGeom prst="rect">
+            <a:avLst/>
+          </a:prstGeom>
+          <a:noFill/>
+          <a:ln/>
+        </p:spPr>
+        <p:txBody>
+          <a:bodyPr wrap="square" rtlCol="0" anchor="ctr"/>
+          <a:lstStyle/>
+          <a:p>
+            <a:pPr marL="0" indent="0">
+              <a:buNone/>
+            </a:pPr>
+            <a:r>
+              <a:rPr lang="en-US" sz="1650" b="1" dirty="0">
+                <a:solidFill>
+                  <a:srgbClr val="141A24"/>
+                </a:solidFill>
+                <a:latin typeface="Arial" pitchFamily="34" charset="0"/>
+                <a:ea typeface="Arial" pitchFamily="34" charset="-122"/>
+                <a:cs typeface="Arial" pitchFamily="34" charset="-120"/>
+              </a:rPr>
+              <a:t>NIL has reached high school</a:t>
+            </a:r>
+            <a:endParaRPr lang="en-US" sz="1650" dirty="0"/>
+          </a:p>
+        </p:txBody>
+      </p:sp>
+      <p:sp>
+        <p:nvSpPr>
+          <p:cNvPr id="15" name="Text 10"/>
+          <p:cNvSpPr/>
+          <p:nvPr/>
+        </p:nvSpPr>
+        <p:spPr>
+          <a:xfrm>
+            <a:off x="5440680" y="3749040"/>
+            <a:ext cx="5989320" cy="822960"/>
+          </a:xfrm>
+          <a:prstGeom prst="rect">
+            <a:avLst/>
+          </a:prstGeom>
+          <a:noFill/>
+          <a:ln/>
+        </p:spPr>
+        <p:txBody>
+          <a:bodyPr wrap="square" rtlCol="0" anchor="t"/>
+          <a:lstStyle/>
+          <a:p>
+            <a:pPr marL="0" indent="0">
+              <a:buNone/>
+            </a:pPr>
+            <a:r>
+              <a:rPr lang="en-US" sz="1200" dirty="0">
+                <a:solidFill>
+                  <a:srgbClr val="141A24"/>
+                </a:solidFill>
+                <a:latin typeface="Arial" pitchFamily="34" charset="0"/>
+                <a:ea typeface="Arial" pitchFamily="34" charset="-122"/>
+                <a:cs typeface="Arial" pitchFamily="34" charset="-120"/>
+              </a:rPr>
+              <a:t>North and South Carolina now permit HS NIL — a first-mover market for athletes and families navigating offers.</a:t>
+            </a:r>
+            <a:endParaRPr lang="en-US" sz="1200" dirty="0"/>
+          </a:p>
+        </p:txBody>
+      </p:sp>
+      <p:sp>
+        <p:nvSpPr>
+          <p:cNvPr id="16" name="Shape 11"/>
+          <p:cNvSpPr/>
+          <p:nvPr/>
+        </p:nvSpPr>
+        <p:spPr>
+          <a:xfrm>
+            <a:off x="4709160" y="4544568"/>
+            <a:ext cx="6766560" cy="0"/>
+          </a:xfrm>
+          <a:prstGeom prst="line">
+            <a:avLst/>
+          </a:prstGeom>
+          <a:noFill/>
+          <a:ln w="12700">
+            <a:solidFill>
+              <a:srgbClr val="E4E7EC"/>
+            </a:solidFill>
+            <a:prstDash val="solid"/>
+          </a:ln>
+        </p:spPr>
+      </p:sp>
+      <p:pic>
+        <p:nvPicPr>
+          <p:cNvPr id="17" name="Image 3" descr="preencoded.png"/>
+          <p:cNvPicPr>
+            <a:picLocks noChangeAspect="1"/>
+          </p:cNvPicPr>
+          <p:nvPr/>
+        </p:nvPicPr>
+        <p:blipFill>
+          <a:blip r:embed="rId6"/>
+          <a:stretch>
+            <a:fillRect/>
+          </a:stretch>
+        </p:blipFill>
+        <p:spPr>
+          <a:xfrm>
             <a:off x="4709160" y="4754880"/>
             <a:ext cx="475488" cy="475488"/>
           </a:xfrm>
@@ -3116,7 +2815,7 @@
           <a:bodyPr wrap="square" rtlCol="0" anchor="ctr"/>
           <a:lstStyle/>
           <a:p>
-            <a:pPr indent="0" marL="0">
+            <a:pPr marL="0" indent="0">
               <a:buNone/>
             </a:pPr>
             <a:r>
@@ -3155,7 +2854,7 @@
           <a:bodyPr wrap="square" rtlCol="0" anchor="t"/>
           <a:lstStyle/>
           <a:p>
-            <a:pPr indent="0" marL="0">
+            <a:pPr marL="0" indent="0">
               <a:buNone/>
             </a:pPr>
             <a:r>
@@ -3194,7 +2893,7 @@
           <a:bodyPr wrap="square" rtlCol="0" anchor="ctr"/>
           <a:lstStyle/>
           <a:p>
-            <a:pPr indent="0" marL="0">
+            <a:pPr marL="0" indent="0">
               <a:buNone/>
             </a:pPr>
             <a:r>
@@ -3208,9 +2907,6 @@
               </a:rPr>
               <a:t>Dexter Sports Co.</a:t>
             </a:r>
-            <a:pPr indent="0" marL="0">
-              <a:buNone/>
-            </a:pPr>
             <a:r>
               <a:rPr lang="en-US" sz="850" dirty="0">
                 <a:solidFill>
@@ -3242,6 +2938,7 @@
         <a:solidFill>
           <a:srgbClr val="FFFFFF"/>
         </a:solidFill>
+        <a:effectLst/>
       </p:bgPr>
     </p:bg>
     <p:spTree>
@@ -3279,7 +2976,7 @@
           <a:bodyPr wrap="square" rtlCol="0" anchor="ctr"/>
           <a:lstStyle/>
           <a:p>
-            <a:pPr indent="0" marL="0">
+            <a:pPr marL="0" indent="0">
               <a:buNone/>
             </a:pPr>
             <a:r>
@@ -3293,11 +2990,8 @@
               </a:rPr>
               <a:t>● </a:t>
             </a:r>
-            <a:pPr indent="0" marL="0">
-              <a:buNone/>
-            </a:pPr>
-            <a:r>
-              <a:rPr lang="en-US" sz="1100" b="1" spc="300" kern="0" dirty="0">
+            <a:r>
+              <a:rPr lang="en-US" sz="1100" b="1" kern="0" spc="300" dirty="0">
                 <a:solidFill>
                   <a:srgbClr val="2563EB"/>
                 </a:solidFill>
@@ -3332,7 +3026,7 @@
           <a:bodyPr wrap="square" rtlCol="0" anchor="ctr"/>
           <a:lstStyle/>
           <a:p>
-            <a:pPr indent="0" marL="0">
+            <a:pPr marL="0" indent="0">
               <a:buNone/>
             </a:pPr>
             <a:r>
@@ -3346,9 +3040,6 @@
               </a:rPr>
               <a:t>A full pipeline that </a:t>
             </a:r>
-            <a:pPr indent="0" marL="0">
-              <a:buNone/>
-            </a:pPr>
             <a:r>
               <a:rPr lang="en-US" sz="2900" i="1" dirty="0">
                 <a:solidFill>
@@ -3385,7 +3076,7 @@
           <a:bodyPr wrap="square" rtlCol="0" anchor="ctr"/>
           <a:lstStyle/>
           <a:p>
-            <a:pPr indent="0" marL="0">
+            <a:pPr marL="0" indent="0">
               <a:buNone/>
             </a:pPr>
             <a:r>
@@ -3432,14 +3123,14 @@
       </p:sp>
       <p:pic>
         <p:nvPicPr>
-          <p:cNvPr id="6" name="Image 0" descr="preencoded.png">    </p:cNvPr>
+          <p:cNvPr id="6" name="Image 0" descr="preencoded.png"/>
           <p:cNvPicPr>
             <a:picLocks noChangeAspect="1"/>
           </p:cNvPicPr>
           <p:nvPr/>
         </p:nvPicPr>
         <p:blipFill>
-          <a:blip r:embed="rId1"/>
+          <a:blip r:embed="rId3"/>
           <a:stretch>
             <a:fillRect/>
           </a:stretch>
@@ -3475,7 +3166,7 @@
           <a:bodyPr wrap="square" rtlCol="0" anchor="ctr"/>
           <a:lstStyle/>
           <a:p>
-            <a:pPr indent="0" marL="0">
+            <a:pPr marL="0" indent="0">
               <a:buNone/>
             </a:pPr>
             <a:r>
@@ -3489,9 +3180,6 @@
               </a:rPr>
               <a:t>~2/3</a:t>
             </a:r>
-            <a:pPr indent="0" marL="0">
-              <a:buNone/>
-            </a:pPr>
             <a:r>
               <a:rPr lang="en-US" sz="1400" b="1" dirty="0">
                 <a:solidFill>
@@ -3528,7 +3216,7 @@
           <a:bodyPr wrap="square" rtlCol="0" anchor="t"/>
           <a:lstStyle/>
           <a:p>
-            <a:pPr indent="0" marL="0">
+            <a:pPr marL="0" indent="0">
               <a:lnSpc>
                 <a:spcPct val="105000"/>
               </a:lnSpc>
@@ -3578,14 +3266,14 @@
       </p:sp>
       <p:pic>
         <p:nvPicPr>
-          <p:cNvPr id="10" name="Image 1" descr="preencoded.png">    </p:cNvPr>
+          <p:cNvPr id="10" name="Image 1" descr="preencoded.png"/>
           <p:cNvPicPr>
             <a:picLocks noChangeAspect="1"/>
           </p:cNvPicPr>
           <p:nvPr/>
         </p:nvPicPr>
         <p:blipFill>
-          <a:blip r:embed="rId2"/>
+          <a:blip r:embed="rId4"/>
           <a:stretch>
             <a:fillRect/>
           </a:stretch>
@@ -3621,7 +3309,7 @@
           <a:bodyPr wrap="square" rtlCol="0" anchor="ctr"/>
           <a:lstStyle/>
           <a:p>
-            <a:pPr indent="0" marL="0">
+            <a:pPr marL="0" indent="0">
               <a:buNone/>
             </a:pPr>
             <a:r>
@@ -3635,9 +3323,6 @@
               </a:rPr>
               <a:t>46%</a:t>
             </a:r>
-            <a:pPr indent="0" marL="0">
-              <a:buNone/>
-            </a:pPr>
             <a:r>
               <a:rPr lang="en-US" sz="1400" b="1" dirty="0">
                 <a:solidFill>
@@ -3674,7 +3359,7 @@
           <a:bodyPr wrap="square" rtlCol="0" anchor="t"/>
           <a:lstStyle/>
           <a:p>
-            <a:pPr indent="0" marL="0">
+            <a:pPr marL="0" indent="0">
               <a:lnSpc>
                 <a:spcPct val="105000"/>
               </a:lnSpc>
@@ -3724,14 +3409,14 @@
       </p:sp>
       <p:pic>
         <p:nvPicPr>
-          <p:cNvPr id="14" name="Image 2" descr="preencoded.png">    </p:cNvPr>
+          <p:cNvPr id="14" name="Image 2" descr="preencoded.png"/>
           <p:cNvPicPr>
             <a:picLocks noChangeAspect="1"/>
           </p:cNvPicPr>
           <p:nvPr/>
         </p:nvPicPr>
         <p:blipFill>
-          <a:blip r:embed="rId3"/>
+          <a:blip r:embed="rId5"/>
           <a:stretch>
             <a:fillRect/>
           </a:stretch>
@@ -3767,7 +3452,7 @@
           <a:bodyPr wrap="square" rtlCol="0" anchor="ctr"/>
           <a:lstStyle/>
           <a:p>
-            <a:pPr indent="0" marL="0">
+            <a:pPr marL="0" indent="0">
               <a:buNone/>
             </a:pPr>
             <a:r>
@@ -3781,9 +3466,6 @@
               </a:rPr>
               <a:t>7.3%</a:t>
             </a:r>
-            <a:pPr indent="0" marL="0">
-              <a:buNone/>
-            </a:pPr>
             <a:r>
               <a:rPr lang="en-US" sz="1400" b="1" dirty="0">
                 <a:solidFill>
@@ -3820,7 +3502,7 @@
           <a:bodyPr wrap="square" rtlCol="0" anchor="t"/>
           <a:lstStyle/>
           <a:p>
-            <a:pPr indent="0" marL="0">
+            <a:pPr marL="0" indent="0">
               <a:lnSpc>
                 <a:spcPct val="105000"/>
               </a:lnSpc>
@@ -3870,14 +3552,14 @@
       </p:sp>
       <p:pic>
         <p:nvPicPr>
-          <p:cNvPr id="18" name="Image 3" descr="preencoded.png">    </p:cNvPr>
+          <p:cNvPr id="18" name="Image 3" descr="preencoded.png"/>
           <p:cNvPicPr>
             <a:picLocks noChangeAspect="1"/>
           </p:cNvPicPr>
           <p:nvPr/>
         </p:nvPicPr>
         <p:blipFill>
-          <a:blip r:embed="rId4"/>
+          <a:blip r:embed="rId6"/>
           <a:stretch>
             <a:fillRect/>
           </a:stretch>
@@ -3913,7 +3595,7 @@
           <a:bodyPr wrap="square" rtlCol="0" anchor="ctr"/>
           <a:lstStyle/>
           <a:p>
-            <a:pPr indent="0" marL="0">
+            <a:pPr marL="0" indent="0">
               <a:buNone/>
             </a:pPr>
             <a:r>
@@ -3927,9 +3609,6 @@
               </a:rPr>
               <a:t>43 / 55%</a:t>
             </a:r>
-            <a:pPr indent="0" marL="0">
-              <a:buNone/>
-            </a:pPr>
             <a:r>
               <a:rPr lang="en-US" sz="1400" b="1" dirty="0">
                 <a:solidFill>
@@ -3966,7 +3645,7 @@
           <a:bodyPr wrap="square" rtlCol="0" anchor="t"/>
           <a:lstStyle/>
           <a:p>
-            <a:pPr indent="0" marL="0">
+            <a:pPr marL="0" indent="0">
               <a:lnSpc>
                 <a:spcPct val="105000"/>
               </a:lnSpc>
@@ -4011,14 +3690,14 @@
       </p:sp>
       <p:pic>
         <p:nvPicPr>
-          <p:cNvPr id="22" name="Image 4" descr="preencoded.png">    </p:cNvPr>
+          <p:cNvPr id="22" name="Image 4" descr="preencoded.png"/>
           <p:cNvPicPr>
             <a:picLocks noChangeAspect="1"/>
           </p:cNvPicPr>
           <p:nvPr/>
         </p:nvPicPr>
         <p:blipFill>
-          <a:blip r:embed="rId5"/>
+          <a:blip r:embed="rId7"/>
           <a:stretch>
             <a:fillRect/>
           </a:stretch>
@@ -4054,7 +3733,7 @@
           <a:bodyPr wrap="square" rtlCol="0" anchor="ctr"/>
           <a:lstStyle/>
           <a:p>
-            <a:pPr indent="0" marL="0">
+            <a:pPr marL="0" indent="0">
               <a:lnSpc>
                 <a:spcPct val="106000"/>
               </a:lnSpc>
@@ -4071,12 +3750,6 @@
               </a:rPr>
               <a:t>A full pipeline, a narrow top.  </a:t>
             </a:r>
-            <a:pPr indent="0" marL="0">
-              <a:lnSpc>
-                <a:spcPct val="106000"/>
-              </a:lnSpc>
-              <a:buNone/>
-            </a:pPr>
             <a:r>
               <a:rPr lang="en-US" sz="1150" dirty="0">
                 <a:solidFill>
@@ -4113,7 +3786,7 @@
           <a:bodyPr wrap="square" rtlCol="0" anchor="ctr"/>
           <a:lstStyle/>
           <a:p>
-            <a:pPr indent="0" marL="0">
+            <a:pPr marL="0" indent="0">
               <a:buNone/>
             </a:pPr>
             <a:r>
@@ -4147,6 +3820,7 @@
         <a:solidFill>
           <a:srgbClr val="FFFFFF"/>
         </a:solidFill>
+        <a:effectLst/>
       </p:bgPr>
     </p:bg>
     <p:spTree>
@@ -4184,7 +3858,7 @@
           <a:bodyPr wrap="square" rtlCol="0" anchor="ctr"/>
           <a:lstStyle/>
           <a:p>
-            <a:pPr indent="0" marL="0">
+            <a:pPr marL="0" indent="0">
               <a:buNone/>
             </a:pPr>
             <a:r>
@@ -4198,11 +3872,8 @@
               </a:rPr>
               <a:t>● </a:t>
             </a:r>
-            <a:pPr indent="0" marL="0">
-              <a:buNone/>
-            </a:pPr>
-            <a:r>
-              <a:rPr lang="en-US" sz="1100" b="1" spc="300" kern="0" dirty="0">
+            <a:r>
+              <a:rPr lang="en-US" sz="1100" b="1" kern="0" spc="300" dirty="0">
                 <a:solidFill>
                   <a:srgbClr val="2563EB"/>
                 </a:solidFill>
@@ -4237,7 +3908,7 @@
           <a:bodyPr wrap="square" rtlCol="0" anchor="ctr"/>
           <a:lstStyle/>
           <a:p>
-            <a:pPr indent="0" marL="0">
+            <a:pPr marL="0" indent="0">
               <a:buNone/>
             </a:pPr>
             <a:r>
@@ -4251,9 +3922,6 @@
               </a:rPr>
               <a:t>The coaches the big agencies </a:t>
             </a:r>
-            <a:pPr indent="0" marL="0">
-              <a:buNone/>
-            </a:pPr>
             <a:r>
               <a:rPr lang="en-US" sz="2900" i="1" dirty="0">
                 <a:solidFill>
@@ -4290,7 +3958,7 @@
           <a:bodyPr wrap="square" rtlCol="0" anchor="ctr"/>
           <a:lstStyle/>
           <a:p>
-            <a:pPr indent="0" marL="0">
+            <a:pPr marL="0" indent="0">
               <a:buNone/>
             </a:pPr>
             <a:r>
@@ -4359,14 +4027,14 @@
       </p:sp>
       <p:pic>
         <p:nvPicPr>
-          <p:cNvPr id="7" name="Image 0" descr="preencoded.png">    </p:cNvPr>
+          <p:cNvPr id="7" name="Image 0" descr="preencoded.png"/>
           <p:cNvPicPr>
             <a:picLocks noChangeAspect="1"/>
           </p:cNvPicPr>
           <p:nvPr/>
         </p:nvPicPr>
         <p:blipFill>
-          <a:blip r:embed="rId1"/>
+          <a:blip r:embed="rId3"/>
           <a:stretch>
             <a:fillRect/>
           </a:stretch>
@@ -4402,7 +4070,7 @@
           <a:bodyPr wrap="square" rtlCol="0" anchor="t"/>
           <a:lstStyle/>
           <a:p>
-            <a:pPr indent="0" marL="0">
+            <a:pPr marL="0" indent="0">
               <a:buNone/>
             </a:pPr>
             <a:r>
@@ -4441,7 +4109,7 @@
           <a:bodyPr wrap="square" rtlCol="0" anchor="t"/>
           <a:lstStyle/>
           <a:p>
-            <a:pPr indent="0" marL="0">
+            <a:pPr marL="0" indent="0">
               <a:lnSpc>
                 <a:spcPct val="112000"/>
               </a:lnSpc>
@@ -4513,14 +4181,14 @@
       </p:sp>
       <p:pic>
         <p:nvPicPr>
-          <p:cNvPr id="12" name="Image 1" descr="preencoded.png">    </p:cNvPr>
+          <p:cNvPr id="12" name="Image 1" descr="preencoded.png"/>
           <p:cNvPicPr>
             <a:picLocks noChangeAspect="1"/>
           </p:cNvPicPr>
           <p:nvPr/>
         </p:nvPicPr>
         <p:blipFill>
-          <a:blip r:embed="rId2"/>
+          <a:blip r:embed="rId4"/>
           <a:stretch>
             <a:fillRect/>
           </a:stretch>
@@ -4556,7 +4224,7 @@
           <a:bodyPr wrap="square" rtlCol="0" anchor="t"/>
           <a:lstStyle/>
           <a:p>
-            <a:pPr indent="0" marL="0">
+            <a:pPr marL="0" indent="0">
               <a:buNone/>
             </a:pPr>
             <a:r>
@@ -4595,7 +4263,7 @@
           <a:bodyPr wrap="square" rtlCol="0" anchor="t"/>
           <a:lstStyle/>
           <a:p>
-            <a:pPr indent="0" marL="0">
+            <a:pPr marL="0" indent="0">
               <a:lnSpc>
                 <a:spcPct val="112000"/>
               </a:lnSpc>
@@ -4667,14 +4335,14 @@
       </p:sp>
       <p:pic>
         <p:nvPicPr>
-          <p:cNvPr id="17" name="Image 2" descr="preencoded.png">    </p:cNvPr>
+          <p:cNvPr id="17" name="Image 2" descr="preencoded.png"/>
           <p:cNvPicPr>
             <a:picLocks noChangeAspect="1"/>
           </p:cNvPicPr>
           <p:nvPr/>
         </p:nvPicPr>
         <p:blipFill>
-          <a:blip r:embed="rId3"/>
+          <a:blip r:embed="rId5"/>
           <a:stretch>
             <a:fillRect/>
           </a:stretch>
@@ -4710,7 +4378,7 @@
           <a:bodyPr wrap="square" rtlCol="0" anchor="t"/>
           <a:lstStyle/>
           <a:p>
-            <a:pPr indent="0" marL="0">
+            <a:pPr marL="0" indent="0">
               <a:buNone/>
             </a:pPr>
             <a:r>
@@ -4749,7 +4417,7 @@
           <a:bodyPr wrap="square" rtlCol="0" anchor="t"/>
           <a:lstStyle/>
           <a:p>
-            <a:pPr indent="0" marL="0">
+            <a:pPr marL="0" indent="0">
               <a:lnSpc>
                 <a:spcPct val="112000"/>
               </a:lnSpc>
@@ -4791,7 +4459,7 @@
           <a:bodyPr wrap="square" rtlCol="0" anchor="ctr"/>
           <a:lstStyle/>
           <a:p>
-            <a:pPr indent="0" marL="0">
+            <a:pPr marL="0" indent="0">
               <a:buNone/>
             </a:pPr>
             <a:r>
@@ -4805,9 +4473,6 @@
               </a:rPr>
               <a:t>Dexter Sports Co.</a:t>
             </a:r>
-            <a:pPr indent="0" marL="0">
-              <a:buNone/>
-            </a:pPr>
             <a:r>
               <a:rPr lang="en-US" sz="850" dirty="0">
                 <a:solidFill>
@@ -4839,6 +4504,7 @@
         <a:solidFill>
           <a:srgbClr val="FFFFFF"/>
         </a:solidFill>
+        <a:effectLst/>
       </p:bgPr>
     </p:bg>
     <p:spTree>
@@ -4876,7 +4542,7 @@
           <a:bodyPr wrap="square" rtlCol="0" anchor="ctr"/>
           <a:lstStyle/>
           <a:p>
-            <a:pPr indent="0" marL="0">
+            <a:pPr marL="0" indent="0">
               <a:buNone/>
             </a:pPr>
             <a:r>
@@ -4890,11 +4556,8 @@
               </a:rPr>
               <a:t>● </a:t>
             </a:r>
-            <a:pPr indent="0" marL="0">
-              <a:buNone/>
-            </a:pPr>
-            <a:r>
-              <a:rPr lang="en-US" sz="1100" b="1" spc="300" kern="0" dirty="0">
+            <a:r>
+              <a:rPr lang="en-US" sz="1100" b="1" kern="0" spc="300" dirty="0">
                 <a:solidFill>
                   <a:srgbClr val="2563EB"/>
                 </a:solidFill>
@@ -4929,7 +4592,7 @@
           <a:bodyPr wrap="square" rtlCol="0" anchor="ctr"/>
           <a:lstStyle/>
           <a:p>
-            <a:pPr indent="0" marL="0">
+            <a:pPr marL="0" indent="0">
               <a:buNone/>
             </a:pPr>
             <a:r>
@@ -4943,9 +4606,6 @@
               </a:rPr>
               <a:t>Part of a new wave of </a:t>
             </a:r>
-            <a:pPr indent="0" marL="0">
-              <a:buNone/>
-            </a:pPr>
             <a:r>
               <a:rPr lang="en-US" sz="2900" i="1" dirty="0">
                 <a:solidFill>
@@ -4982,7 +4642,7 @@
           <a:bodyPr wrap="square" rtlCol="0" anchor="ctr"/>
           <a:lstStyle/>
           <a:p>
-            <a:pPr indent="0" marL="0">
+            <a:pPr marL="0" indent="0">
               <a:buNone/>
             </a:pPr>
             <a:r>
@@ -5051,14 +4711,14 @@
       </p:sp>
       <p:pic>
         <p:nvPicPr>
-          <p:cNvPr id="7" name="Image 0" descr="preencoded.png">    </p:cNvPr>
+          <p:cNvPr id="7" name="Image 0" descr="preencoded.png"/>
           <p:cNvPicPr>
             <a:picLocks noChangeAspect="1"/>
           </p:cNvPicPr>
           <p:nvPr/>
         </p:nvPicPr>
         <p:blipFill>
-          <a:blip r:embed="rId1"/>
+          <a:blip r:embed="rId3"/>
           <a:stretch>
             <a:fillRect/>
           </a:stretch>
@@ -5094,7 +4754,7 @@
           <a:bodyPr wrap="square" rtlCol="0" anchor="ctr"/>
           <a:lstStyle/>
           <a:p>
-            <a:pPr indent="0" marL="0">
+            <a:pPr marL="0" indent="0">
               <a:buNone/>
             </a:pPr>
             <a:r>
@@ -5133,7 +4793,7 @@
           <a:bodyPr wrap="square" rtlCol="0" anchor="t"/>
           <a:lstStyle/>
           <a:p>
-            <a:pPr indent="0" marL="0">
+            <a:pPr marL="0" indent="0">
               <a:lnSpc>
                 <a:spcPct val="112000"/>
               </a:lnSpc>
@@ -5202,7 +4862,7 @@
           <a:bodyPr wrap="square" rtlCol="0" anchor="ctr"/>
           <a:lstStyle/>
           <a:p>
-            <a:pPr algn="ctr" indent="0" marL="0">
+            <a:pPr marL="0" indent="0" algn="ctr">
               <a:buNone/>
             </a:pPr>
             <a:r>
@@ -5271,14 +4931,14 @@
       </p:sp>
       <p:pic>
         <p:nvPicPr>
-          <p:cNvPr id="14" name="Image 1" descr="preencoded.png">    </p:cNvPr>
+          <p:cNvPr id="14" name="Image 1" descr="preencoded.png"/>
           <p:cNvPicPr>
             <a:picLocks noChangeAspect="1"/>
           </p:cNvPicPr>
           <p:nvPr/>
         </p:nvPicPr>
         <p:blipFill>
-          <a:blip r:embed="rId2"/>
+          <a:blip r:embed="rId4"/>
           <a:stretch>
             <a:fillRect/>
           </a:stretch>
@@ -5314,7 +4974,7 @@
           <a:bodyPr wrap="square" rtlCol="0" anchor="ctr"/>
           <a:lstStyle/>
           <a:p>
-            <a:pPr indent="0" marL="0">
+            <a:pPr marL="0" indent="0">
               <a:buNone/>
             </a:pPr>
             <a:r>
@@ -5353,7 +5013,7 @@
           <a:bodyPr wrap="square" rtlCol="0" anchor="t"/>
           <a:lstStyle/>
           <a:p>
-            <a:pPr indent="0" marL="0">
+            <a:pPr marL="0" indent="0">
               <a:lnSpc>
                 <a:spcPct val="112000"/>
               </a:lnSpc>
@@ -5422,7 +5082,7 @@
           <a:bodyPr wrap="square" rtlCol="0" anchor="ctr"/>
           <a:lstStyle/>
           <a:p>
-            <a:pPr algn="ctr" indent="0" marL="0">
+            <a:pPr marL="0" indent="0" algn="ctr">
               <a:buNone/>
             </a:pPr>
             <a:r>
@@ -5491,14 +5151,14 @@
       </p:sp>
       <p:pic>
         <p:nvPicPr>
-          <p:cNvPr id="21" name="Image 2" descr="preencoded.png">    </p:cNvPr>
+          <p:cNvPr id="21" name="Image 2" descr="preencoded.png"/>
           <p:cNvPicPr>
             <a:picLocks noChangeAspect="1"/>
           </p:cNvPicPr>
           <p:nvPr/>
         </p:nvPicPr>
         <p:blipFill>
-          <a:blip r:embed="rId3"/>
+          <a:blip r:embed="rId5"/>
           <a:stretch>
             <a:fillRect/>
           </a:stretch>
@@ -5534,7 +5194,7 @@
           <a:bodyPr wrap="square" rtlCol="0" anchor="ctr"/>
           <a:lstStyle/>
           <a:p>
-            <a:pPr indent="0" marL="0">
+            <a:pPr marL="0" indent="0">
               <a:buNone/>
             </a:pPr>
             <a:r>
@@ -5573,7 +5233,7 @@
           <a:bodyPr wrap="square" rtlCol="0" anchor="t"/>
           <a:lstStyle/>
           <a:p>
-            <a:pPr indent="0" marL="0">
+            <a:pPr marL="0" indent="0">
               <a:lnSpc>
                 <a:spcPct val="112000"/>
               </a:lnSpc>
@@ -5642,7 +5302,7 @@
           <a:bodyPr wrap="square" rtlCol="0" anchor="ctr"/>
           <a:lstStyle/>
           <a:p>
-            <a:pPr algn="ctr" indent="0" marL="0">
+            <a:pPr marL="0" indent="0" algn="ctr">
               <a:buNone/>
             </a:pPr>
             <a:r>
@@ -5681,7 +5341,7 @@
           <a:bodyPr wrap="square" rtlCol="0" anchor="ctr"/>
           <a:lstStyle/>
           <a:p>
-            <a:pPr indent="0" marL="0">
+            <a:pPr marL="0" indent="0">
               <a:buNone/>
             </a:pPr>
             <a:r>
@@ -5720,7 +5380,7 @@
           <a:bodyPr wrap="square" rtlCol="0" anchor="ctr"/>
           <a:lstStyle/>
           <a:p>
-            <a:pPr indent="0" marL="0">
+            <a:pPr marL="0" indent="0">
               <a:buNone/>
             </a:pPr>
             <a:r>
@@ -5734,9 +5394,6 @@
               </a:rPr>
               <a:t>Dexter Sports Co.</a:t>
             </a:r>
-            <a:pPr indent="0" marL="0">
-              <a:buNone/>
-            </a:pPr>
             <a:r>
               <a:rPr lang="en-US" sz="850" dirty="0">
                 <a:solidFill>
@@ -5768,6 +5425,7 @@
         <a:solidFill>
           <a:srgbClr val="FFFFFF"/>
         </a:solidFill>
+        <a:effectLst/>
       </p:bgPr>
     </p:bg>
     <p:spTree>
@@ -5805,11 +5463,11 @@
           <a:bodyPr wrap="square" rtlCol="0" anchor="ctr"/>
           <a:lstStyle/>
           <a:p>
-            <a:pPr indent="0" marL="0">
-              <a:buNone/>
-            </a:pPr>
-            <a:r>
-              <a:rPr lang="en-US" sz="800" dirty="0">
+            <a:pPr marL="0" indent="0">
+              <a:buNone/>
+            </a:pPr>
+            <a:r>
+              <a:rPr lang="en-US" sz="800">
                 <a:solidFill>
                   <a:srgbClr val="2563EB"/>
                 </a:solidFill>
@@ -5819,11 +5477,8 @@
               </a:rPr>
               <a:t>● </a:t>
             </a:r>
-            <a:pPr indent="0" marL="0">
-              <a:buNone/>
-            </a:pPr>
-            <a:r>
-              <a:rPr lang="en-US" sz="1100" b="1" spc="300" kern="0" dirty="0">
+            <a:r>
+              <a:rPr lang="en-US" sz="1100" b="1" kern="0" spc="300">
                 <a:solidFill>
                   <a:srgbClr val="2563EB"/>
                 </a:solidFill>
@@ -5831,7 +5486,7 @@
                 <a:ea typeface="Arial" pitchFamily="34" charset="-122"/>
                 <a:cs typeface="Arial" pitchFamily="34" charset="-120"/>
               </a:rPr>
-              <a:t>REGIONS OF FOCUS</a:t>
+              <a:t>HEADQUARTERS</a:t>
             </a:r>
             <a:endParaRPr lang="en-US" sz="1100" dirty="0"/>
           </a:p>
@@ -5858,11 +5513,11 @@
           <a:bodyPr wrap="square" rtlCol="0" anchor="ctr"/>
           <a:lstStyle/>
           <a:p>
-            <a:pPr indent="0" marL="0">
-              <a:buNone/>
-            </a:pPr>
-            <a:r>
-              <a:rPr lang="en-US" sz="2900" b="1" dirty="0">
+            <a:pPr marL="0" indent="0">
+              <a:buNone/>
+            </a:pPr>
+            <a:r>
+              <a:rPr lang="en-US" sz="2900" b="1">
                 <a:solidFill>
                   <a:srgbClr val="141A24"/>
                 </a:solidFill>
@@ -5870,21 +5525,7 @@
                 <a:ea typeface="Arial" pitchFamily="34" charset="-122"/>
                 <a:cs typeface="Arial" pitchFamily="34" charset="-120"/>
               </a:rPr>
-              <a:t>Where the peers sit — and where </a:t>
-            </a:r>
-            <a:pPr indent="0" marL="0">
-              <a:buNone/>
-            </a:pPr>
-            <a:r>
-              <a:rPr lang="en-US" sz="2900" i="1" dirty="0">
-                <a:solidFill>
-                  <a:srgbClr val="2563EB"/>
-                </a:solidFill>
-                <a:latin typeface="Georgia" pitchFamily="34" charset="0"/>
-                <a:ea typeface="Georgia" pitchFamily="34" charset="-122"/>
-                <a:cs typeface="Georgia" pitchFamily="34" charset="-120"/>
-              </a:rPr>
-              <a:t>we focus.</a:t>
+              <a:t>Where each agency is headquartered.</a:t>
             </a:r>
             <a:endParaRPr lang="en-US" sz="2900" dirty="0"/>
           </a:p>
@@ -5911,11 +5552,11 @@
           <a:bodyPr wrap="square" rtlCol="0" anchor="ctr"/>
           <a:lstStyle/>
           <a:p>
-            <a:pPr indent="0" marL="0">
-              <a:buNone/>
-            </a:pPr>
-            <a:r>
-              <a:rPr lang="en-US" sz="1350" i="1" dirty="0">
+            <a:pPr marL="0" indent="0">
+              <a:buNone/>
+            </a:pPr>
+            <a:r>
+              <a:rPr lang="en-US" sz="1350" i="1">
                 <a:solidFill>
                   <a:srgbClr val="6B7280"/>
                 </a:solidFill>
@@ -5923,7 +5564,7 @@
                 <a:ea typeface="Arial" pitchFamily="34" charset="-122"/>
                 <a:cs typeface="Arial" pitchFamily="34" charset="-120"/>
               </a:rPr>
-              <a:t>A national movement with local roots. Dexter is built in the Carolinas, for the Southeast and beyond.</a:t>
+              <a:t>Founder-led, women-built agencies are based across the country. Dexter Sports Co. is headquartered in Charlotte, NC.</a:t>
             </a:r>
             <a:endParaRPr lang="en-US" sz="1350" dirty="0"/>
           </a:p>
@@ -5931,14 +5572,20 @@
       </p:sp>
       <p:pic>
         <p:nvPicPr>
-          <p:cNvPr id="5" name="Image 0" descr="/home/claude/us_map.png">    </p:cNvPr>
+          <p:cNvPr id="24" name="Picture 23">
+            <a:extLst>
+              <a:ext uri="{FF2B5EF4-FFF2-40B4-BE49-F238E27FC236}">
+                <a16:creationId xmlns:a16="http://schemas.microsoft.com/office/drawing/2014/main" id="{232C8881-1EB5-94BE-0855-DF7249B83659}"/>
+              </a:ext>
+            </a:extLst>
+          </p:cNvPr>
           <p:cNvPicPr>
-            <a:picLocks noChangeAspect="1"/>
+            <a:picLocks/>
           </p:cNvPicPr>
           <p:nvPr/>
         </p:nvPicPr>
         <p:blipFill>
-          <a:blip r:embed="rId1"/>
+          <a:blip r:embed="rId3"/>
           <a:stretch>
             <a:fillRect/>
           </a:stretch>
@@ -5974,11 +5621,11 @@
           <a:bodyPr wrap="square" rtlCol="0" anchor="ctr"/>
           <a:lstStyle/>
           <a:p>
-            <a:pPr indent="0" marL="0">
-              <a:buNone/>
-            </a:pPr>
-            <a:r>
-              <a:rPr lang="en-US" sz="1000" b="1" spc="200" kern="0" dirty="0">
+            <a:pPr marL="0" indent="0">
+              <a:buNone/>
+            </a:pPr>
+            <a:r>
+              <a:rPr lang="en-US" sz="1000" b="1" kern="0" spc="200">
                 <a:solidFill>
                   <a:srgbClr val="6B7280"/>
                 </a:solidFill>
@@ -5986,7 +5633,7 @@
                 <a:ea typeface="Arial" pitchFamily="34" charset="-122"/>
                 <a:cs typeface="Arial" pitchFamily="34" charset="-120"/>
               </a:rPr>
-              <a:t>HOME BASE</a:t>
+              <a:t>HEADQUARTERS</a:t>
             </a:r>
             <a:endParaRPr lang="en-US" sz="1000" dirty="0"/>
           </a:p>
@@ -6011,6 +5658,13 @@
           </a:solidFill>
           <a:ln/>
         </p:spPr>
+        <p:txBody>
+          <a:bodyPr/>
+          <a:lstStyle/>
+          <a:p>
+            <a:endParaRPr lang="en-US"/>
+          </a:p>
+        </p:txBody>
       </p:sp>
       <p:sp>
         <p:nvSpPr>
@@ -6033,7 +5687,7 @@
           <a:bodyPr wrap="square" rtlCol="0" anchor="ctr"/>
           <a:lstStyle/>
           <a:p>
-            <a:pPr indent="0" marL="0">
+            <a:pPr marL="0" indent="0">
               <a:buNone/>
             </a:pPr>
             <a:r>
@@ -6072,7 +5726,7 @@
           <a:bodyPr wrap="square" rtlCol="0" anchor="ctr"/>
           <a:lstStyle/>
           <a:p>
-            <a:pPr indent="0" marL="0">
+            <a:pPr marL="0" indent="0">
               <a:buNone/>
             </a:pPr>
             <a:r>
@@ -6109,6 +5763,13 @@
           </a:solidFill>
           <a:ln/>
         </p:spPr>
+        <p:txBody>
+          <a:bodyPr/>
+          <a:lstStyle/>
+          <a:p>
+            <a:endParaRPr lang="en-US"/>
+          </a:p>
+        </p:txBody>
       </p:sp>
       <p:sp>
         <p:nvSpPr>
@@ -6131,7 +5792,7 @@
           <a:bodyPr wrap="square" rtlCol="0" anchor="ctr"/>
           <a:lstStyle/>
           <a:p>
-            <a:pPr indent="0" marL="0">
+            <a:pPr marL="0" indent="0">
               <a:buNone/>
             </a:pPr>
             <a:r>
@@ -6170,7 +5831,7 @@
           <a:bodyPr wrap="square" rtlCol="0" anchor="ctr"/>
           <a:lstStyle/>
           <a:p>
-            <a:pPr indent="0" marL="0">
+            <a:pPr marL="0" indent="0">
               <a:buNone/>
             </a:pPr>
             <a:r>
@@ -6207,6 +5868,13 @@
           </a:solidFill>
           <a:ln/>
         </p:spPr>
+        <p:txBody>
+          <a:bodyPr/>
+          <a:lstStyle/>
+          <a:p>
+            <a:endParaRPr lang="en-US"/>
+          </a:p>
+        </p:txBody>
       </p:sp>
       <p:sp>
         <p:nvSpPr>
@@ -6229,7 +5897,7 @@
           <a:bodyPr wrap="square" rtlCol="0" anchor="ctr"/>
           <a:lstStyle/>
           <a:p>
-            <a:pPr indent="0" marL="0">
+            <a:pPr marL="0" indent="0">
               <a:buNone/>
             </a:pPr>
             <a:r>
@@ -6268,7 +5936,7 @@
           <a:bodyPr wrap="square" rtlCol="0" anchor="ctr"/>
           <a:lstStyle/>
           <a:p>
-            <a:pPr indent="0" marL="0">
+            <a:pPr marL="0" indent="0">
               <a:buNone/>
             </a:pPr>
             <a:r>
@@ -6305,6 +5973,13 @@
           </a:solidFill>
           <a:ln/>
         </p:spPr>
+        <p:txBody>
+          <a:bodyPr/>
+          <a:lstStyle/>
+          <a:p>
+            <a:endParaRPr lang="en-US"/>
+          </a:p>
+        </p:txBody>
       </p:sp>
       <p:sp>
         <p:nvSpPr>
@@ -6327,7 +6002,7 @@
           <a:bodyPr wrap="square" rtlCol="0" anchor="ctr"/>
           <a:lstStyle/>
           <a:p>
-            <a:pPr indent="0" marL="0">
+            <a:pPr marL="0" indent="0">
               <a:buNone/>
             </a:pPr>
             <a:r>
@@ -6366,7 +6041,7 @@
           <a:bodyPr wrap="square" rtlCol="0" anchor="ctr"/>
           <a:lstStyle/>
           <a:p>
-            <a:pPr indent="0" marL="0">
+            <a:pPr marL="0" indent="0">
               <a:buNone/>
             </a:pPr>
             <a:r>
@@ -6403,6 +6078,13 @@
           </a:solidFill>
           <a:ln/>
         </p:spPr>
+        <p:txBody>
+          <a:bodyPr/>
+          <a:lstStyle/>
+          <a:p>
+            <a:endParaRPr lang="en-US"/>
+          </a:p>
+        </p:txBody>
       </p:sp>
       <p:sp>
         <p:nvSpPr>
@@ -6425,7 +6107,7 @@
           <a:bodyPr wrap="square" rtlCol="0" anchor="ctr"/>
           <a:lstStyle/>
           <a:p>
-            <a:pPr indent="0" marL="0">
+            <a:pPr marL="0" indent="0">
               <a:buNone/>
             </a:pPr>
             <a:r>
@@ -6464,7 +6146,7 @@
           <a:bodyPr wrap="square" rtlCol="0" anchor="ctr"/>
           <a:lstStyle/>
           <a:p>
-            <a:pPr indent="0" marL="0">
+            <a:pPr marL="0" indent="0">
               <a:buNone/>
             </a:pPr>
             <a:r>
@@ -6503,7 +6185,7 @@
           <a:bodyPr wrap="square" rtlCol="0" anchor="ctr"/>
           <a:lstStyle/>
           <a:p>
-            <a:pPr indent="0" marL="0">
+            <a:pPr marL="0" indent="0">
               <a:buNone/>
             </a:pPr>
             <a:r>
@@ -6515,7 +6197,18 @@
                 <a:ea typeface="Arial" pitchFamily="34" charset="-122"/>
                 <a:cs typeface="Arial" pitchFamily="34" charset="-120"/>
               </a:rPr>
-              <a:t>HQ locations per company sites and press. OneForOne publishes no single HQ. Shading marks each agency's home state, not its only market.</a:t>
+              <a:t>HQ locations per company sites and press. OneForOne publishes no single HQ</a:t>
+            </a:r>
+            <a:r>
+              <a:rPr lang="en-US" sz="700" i="1">
+                <a:solidFill>
+                  <a:srgbClr val="6B7280"/>
+                </a:solidFill>
+                <a:latin typeface="Arial" pitchFamily="34" charset="0"/>
+                <a:ea typeface="Arial" pitchFamily="34" charset="-122"/>
+                <a:cs typeface="Arial" pitchFamily="34" charset="-120"/>
+              </a:rPr>
+              <a:t>. Shading marks each agency's headquarters state.</a:t>
             </a:r>
             <a:endParaRPr lang="en-US" sz="700" dirty="0"/>
           </a:p>
@@ -6537,6 +6230,7 @@
         <a:solidFill>
           <a:srgbClr val="0B1220"/>
         </a:solidFill>
+        <a:effectLst/>
       </p:bgPr>
     </p:bg>
     <p:spTree>
@@ -6574,7 +6268,7 @@
           <a:bodyPr wrap="square" rtlCol="0" anchor="ctr"/>
           <a:lstStyle/>
           <a:p>
-            <a:pPr indent="0" marL="0">
+            <a:pPr marL="0" indent="0">
               <a:buNone/>
             </a:pPr>
             <a:r>
@@ -6588,11 +6282,8 @@
               </a:rPr>
               <a:t>● </a:t>
             </a:r>
-            <a:pPr indent="0" marL="0">
-              <a:buNone/>
-            </a:pPr>
-            <a:r>
-              <a:rPr lang="en-US" sz="1100" b="1" spc="300" kern="0" dirty="0">
+            <a:r>
+              <a:rPr lang="en-US" sz="1100" b="1" kern="0" spc="300" dirty="0">
                 <a:solidFill>
                   <a:srgbClr val="93B4FF"/>
                 </a:solidFill>
@@ -6627,7 +6318,7 @@
           <a:bodyPr wrap="square" rtlCol="0" anchor="ctr"/>
           <a:lstStyle/>
           <a:p>
-            <a:pPr indent="0" marL="0">
+            <a:pPr marL="0" indent="0">
               <a:buNone/>
             </a:pPr>
             <a:r>
@@ -6641,9 +6332,6 @@
               </a:rPr>
               <a:t>Led by a former </a:t>
             </a:r>
-            <a:pPr indent="0" marL="0">
-              <a:buNone/>
-            </a:pPr>
             <a:r>
               <a:rPr lang="en-US" sz="2900" i="1" dirty="0">
                 <a:solidFill>
@@ -6680,7 +6368,7 @@
           <a:bodyPr wrap="square" rtlCol="0" anchor="ctr"/>
           <a:lstStyle/>
           <a:p>
-            <a:pPr indent="0" marL="0">
+            <a:pPr marL="0" indent="0">
               <a:buNone/>
             </a:pPr>
             <a:r>
@@ -6719,7 +6407,7 @@
           <a:bodyPr wrap="square" rtlCol="0" anchor="ctr"/>
           <a:lstStyle/>
           <a:p>
-            <a:pPr indent="0" marL="0">
+            <a:pPr marL="0" indent="0">
               <a:buNone/>
             </a:pPr>
             <a:r>
@@ -6758,7 +6446,7 @@
           <a:bodyPr wrap="square" rtlCol="0" anchor="ctr"/>
           <a:lstStyle/>
           <a:p>
-            <a:pPr indent="0" marL="0">
+            <a:pPr marL="0" indent="0">
               <a:buNone/>
             </a:pPr>
             <a:r>
@@ -6824,11 +6512,11 @@
           <a:bodyPr wrap="square" rtlCol="0" anchor="ctr"/>
           <a:lstStyle/>
           <a:p>
-            <a:pPr algn="ctr" indent="0" marL="0">
-              <a:buNone/>
-            </a:pPr>
-            <a:r>
-              <a:rPr lang="en-US" sz="1050" b="1" spc="100" kern="0" dirty="0">
+            <a:pPr marL="0" indent="0" algn="ctr">
+              <a:buNone/>
+            </a:pPr>
+            <a:r>
+              <a:rPr lang="en-US" sz="1050" b="1" kern="0" spc="100" dirty="0">
                 <a:solidFill>
                   <a:srgbClr val="93B4FF"/>
                 </a:solidFill>
@@ -6890,11 +6578,11 @@
           <a:bodyPr wrap="square" rtlCol="0" anchor="ctr"/>
           <a:lstStyle/>
           <a:p>
-            <a:pPr algn="ctr" indent="0" marL="0">
-              <a:buNone/>
-            </a:pPr>
-            <a:r>
-              <a:rPr lang="en-US" sz="1050" b="1" spc="100" kern="0" dirty="0">
+            <a:pPr marL="0" indent="0" algn="ctr">
+              <a:buNone/>
+            </a:pPr>
+            <a:r>
+              <a:rPr lang="en-US" sz="1050" b="1" kern="0" spc="100" dirty="0">
                 <a:solidFill>
                   <a:srgbClr val="93B4FF"/>
                 </a:solidFill>
@@ -6956,11 +6644,11 @@
           <a:bodyPr wrap="square" rtlCol="0" anchor="ctr"/>
           <a:lstStyle/>
           <a:p>
-            <a:pPr algn="ctr" indent="0" marL="0">
-              <a:buNone/>
-            </a:pPr>
-            <a:r>
-              <a:rPr lang="en-US" sz="1050" b="1" spc="100" kern="0" dirty="0">
+            <a:pPr marL="0" indent="0" algn="ctr">
+              <a:buNone/>
+            </a:pPr>
+            <a:r>
+              <a:rPr lang="en-US" sz="1050" b="1" kern="0" spc="100" dirty="0">
                 <a:solidFill>
                   <a:srgbClr val="93B4FF"/>
                 </a:solidFill>
@@ -6998,261 +6686,7 @@
       </p:sp>
       <p:pic>
         <p:nvPicPr>
-          <p:cNvPr id="14" name="Image 0" descr="preencoded.png">    </p:cNvPr>
-          <p:cNvPicPr>
-            <a:picLocks noChangeAspect="1"/>
-          </p:cNvPicPr>
-          <p:nvPr/>
-        </p:nvPicPr>
-        <p:blipFill>
-          <a:blip r:embed="rId1"/>
-          <a:stretch>
-            <a:fillRect/>
-          </a:stretch>
-        </p:blipFill>
-        <p:spPr>
-          <a:xfrm>
-            <a:off x="6062472" y="2359152"/>
-            <a:ext cx="420624" cy="420624"/>
-          </a:xfrm>
-          <a:prstGeom prst="rect">
-            <a:avLst/>
-          </a:prstGeom>
-        </p:spPr>
-      </p:pic>
-      <p:sp>
-        <p:nvSpPr>
-          <p:cNvPr id="15" name="Text 12"/>
-          <p:cNvSpPr/>
-          <p:nvPr/>
-        </p:nvSpPr>
-        <p:spPr>
-          <a:xfrm>
-            <a:off x="6062472" y="2852928"/>
-            <a:ext cx="2468880" cy="365760"/>
-          </a:xfrm>
-          <a:prstGeom prst="rect">
-            <a:avLst/>
-          </a:prstGeom>
-          <a:noFill/>
-          <a:ln/>
-        </p:spPr>
-        <p:txBody>
-          <a:bodyPr wrap="square" rtlCol="0" anchor="ctr"/>
-          <a:lstStyle/>
-          <a:p>
-            <a:pPr indent="0" marL="0">
-              <a:buNone/>
-            </a:pPr>
-            <a:r>
-              <a:rPr lang="en-US" sz="1350" b="1" dirty="0">
-                <a:solidFill>
-                  <a:srgbClr val="93B4FF"/>
-                </a:solidFill>
-                <a:latin typeface="Arial" pitchFamily="34" charset="0"/>
-                <a:ea typeface="Arial" pitchFamily="34" charset="-122"/>
-                <a:cs typeface="Arial" pitchFamily="34" charset="-120"/>
-              </a:rPr>
-              <a:t>Legal &amp; contracting</a:t>
-            </a:r>
-            <a:endParaRPr lang="en-US" sz="1350" dirty="0"/>
-          </a:p>
-        </p:txBody>
-      </p:sp>
-      <p:sp>
-        <p:nvSpPr>
-          <p:cNvPr id="16" name="Text 13"/>
-          <p:cNvSpPr/>
-          <p:nvPr/>
-        </p:nvSpPr>
-        <p:spPr>
-          <a:xfrm>
-            <a:off x="6062472" y="3200400"/>
-            <a:ext cx="2414016" cy="640080"/>
-          </a:xfrm>
-          <a:prstGeom prst="rect">
-            <a:avLst/>
-          </a:prstGeom>
-          <a:noFill/>
-          <a:ln/>
-        </p:spPr>
-        <p:txBody>
-          <a:bodyPr wrap="square" rtlCol="0" anchor="t"/>
-          <a:lstStyle/>
-          <a:p>
-            <a:pPr indent="0" marL="0">
-              <a:lnSpc>
-                <a:spcPct val="105000"/>
-              </a:lnSpc>
-              <a:buNone/>
-            </a:pPr>
-            <a:r>
-              <a:rPr lang="en-US" sz="980" dirty="0">
-                <a:solidFill>
-                  <a:srgbClr val="C3CAD6"/>
-                </a:solidFill>
-                <a:latin typeface="Arial" pitchFamily="34" charset="0"/>
-                <a:ea typeface="Arial" pitchFamily="34" charset="-122"/>
-                <a:cs typeface="Arial" pitchFamily="34" charset="-120"/>
-              </a:rPr>
-              <a:t>A Juris Master in risk management and compliance — she reviews and negotiates contracts, buyouts and NIL deals directly.</a:t>
-            </a:r>
-            <a:endParaRPr lang="en-US" sz="980" dirty="0"/>
-          </a:p>
-        </p:txBody>
-      </p:sp>
-      <p:sp>
-        <p:nvSpPr>
-          <p:cNvPr id="17" name="Shape 14"/>
-          <p:cNvSpPr/>
-          <p:nvPr/>
-        </p:nvSpPr>
-        <p:spPr>
-          <a:xfrm>
-            <a:off x="9052560" y="2103120"/>
-            <a:ext cx="2926080" cy="1783080"/>
-          </a:xfrm>
-          <a:prstGeom prst="roundRect">
-            <a:avLst>
-              <a:gd name="adj" fmla="val 5128"/>
-            </a:avLst>
-          </a:prstGeom>
-          <a:solidFill>
-            <a:srgbClr val="121A2B"/>
-          </a:solidFill>
-          <a:ln/>
-        </p:spPr>
-      </p:sp>
-      <p:pic>
-        <p:nvPicPr>
-          <p:cNvPr id="18" name="Image 1" descr="preencoded.png">    </p:cNvPr>
-          <p:cNvPicPr>
-            <a:picLocks noChangeAspect="1"/>
-          </p:cNvPicPr>
-          <p:nvPr/>
-        </p:nvPicPr>
-        <p:blipFill>
-          <a:blip r:embed="rId2"/>
-          <a:stretch>
-            <a:fillRect/>
-          </a:stretch>
-        </p:blipFill>
-        <p:spPr>
-          <a:xfrm>
-            <a:off x="9308592" y="2359152"/>
-            <a:ext cx="420624" cy="420624"/>
-          </a:xfrm>
-          <a:prstGeom prst="rect">
-            <a:avLst/>
-          </a:prstGeom>
-        </p:spPr>
-      </p:pic>
-      <p:sp>
-        <p:nvSpPr>
-          <p:cNvPr id="19" name="Text 15"/>
-          <p:cNvSpPr/>
-          <p:nvPr/>
-        </p:nvSpPr>
-        <p:spPr>
-          <a:xfrm>
-            <a:off x="9308592" y="2852928"/>
-            <a:ext cx="2468880" cy="365760"/>
-          </a:xfrm>
-          <a:prstGeom prst="rect">
-            <a:avLst/>
-          </a:prstGeom>
-          <a:noFill/>
-          <a:ln/>
-        </p:spPr>
-        <p:txBody>
-          <a:bodyPr wrap="square" rtlCol="0" anchor="ctr"/>
-          <a:lstStyle/>
-          <a:p>
-            <a:pPr indent="0" marL="0">
-              <a:buNone/>
-            </a:pPr>
-            <a:r>
-              <a:rPr lang="en-US" sz="1350" b="1" dirty="0">
-                <a:solidFill>
-                  <a:srgbClr val="93B4FF"/>
-                </a:solidFill>
-                <a:latin typeface="Arial" pitchFamily="34" charset="0"/>
-                <a:ea typeface="Arial" pitchFamily="34" charset="-122"/>
-                <a:cs typeface="Arial" pitchFamily="34" charset="-120"/>
-              </a:rPr>
-              <a:t>Partnerships &amp; gifts</a:t>
-            </a:r>
-            <a:endParaRPr lang="en-US" sz="1350" dirty="0"/>
-          </a:p>
-        </p:txBody>
-      </p:sp>
-      <p:sp>
-        <p:nvSpPr>
-          <p:cNvPr id="20" name="Text 16"/>
-          <p:cNvSpPr/>
-          <p:nvPr/>
-        </p:nvSpPr>
-        <p:spPr>
-          <a:xfrm>
-            <a:off x="9308592" y="3200400"/>
-            <a:ext cx="2414016" cy="640080"/>
-          </a:xfrm>
-          <a:prstGeom prst="rect">
-            <a:avLst/>
-          </a:prstGeom>
-          <a:noFill/>
-          <a:ln/>
-        </p:spPr>
-        <p:txBody>
-          <a:bodyPr wrap="square" rtlCol="0" anchor="t"/>
-          <a:lstStyle/>
-          <a:p>
-            <a:pPr indent="0" marL="0">
-              <a:lnSpc>
-                <a:spcPct val="105000"/>
-              </a:lnSpc>
-              <a:buNone/>
-            </a:pPr>
-            <a:r>
-              <a:rPr lang="en-US" sz="980" dirty="0">
-                <a:solidFill>
-                  <a:srgbClr val="C3CAD6"/>
-                </a:solidFill>
-                <a:latin typeface="Arial" pitchFamily="34" charset="0"/>
-                <a:ea typeface="Arial" pitchFamily="34" charset="-122"/>
-                <a:cs typeface="Arial" pitchFamily="34" charset="-120"/>
-              </a:rPr>
-              <a:t>CFRE with 10+ years in major gifts, corporate partnerships and sponsorship — the second revenue line, as a core skill.</a:t>
-            </a:r>
-            <a:endParaRPr lang="en-US" sz="980" dirty="0"/>
-          </a:p>
-        </p:txBody>
-      </p:sp>
-      <p:sp>
-        <p:nvSpPr>
-          <p:cNvPr id="21" name="Shape 17"/>
-          <p:cNvSpPr/>
-          <p:nvPr/>
-        </p:nvSpPr>
-        <p:spPr>
-          <a:xfrm>
-            <a:off x="5806440" y="4069080"/>
-            <a:ext cx="2926080" cy="1783080"/>
-          </a:xfrm>
-          <a:prstGeom prst="roundRect">
-            <a:avLst>
-              <a:gd name="adj" fmla="val 5128"/>
-            </a:avLst>
-          </a:prstGeom>
-          <a:solidFill>
-            <a:srgbClr val="121A2B"/>
-          </a:solidFill>
-          <a:ln/>
-        </p:spPr>
-      </p:sp>
-      <p:pic>
-        <p:nvPicPr>
-          <p:cNvPr id="22" name="Image 2" descr="preencoded.png">    </p:cNvPr>
+          <p:cNvPr id="14" name="Image 0" descr="preencoded.png"/>
           <p:cNvPicPr>
             <a:picLocks noChangeAspect="1"/>
           </p:cNvPicPr>
@@ -7266,7 +6700,7 @@
         </p:blipFill>
         <p:spPr>
           <a:xfrm>
-            <a:off x="6062472" y="4325112"/>
+            <a:off x="6062472" y="2359152"/>
             <a:ext cx="420624" cy="420624"/>
           </a:xfrm>
           <a:prstGeom prst="rect">
@@ -7276,13 +6710,13 @@
       </p:pic>
       <p:sp>
         <p:nvSpPr>
-          <p:cNvPr id="23" name="Text 18"/>
-          <p:cNvSpPr/>
-          <p:nvPr/>
-        </p:nvSpPr>
-        <p:spPr>
-          <a:xfrm>
-            <a:off x="6062472" y="4818888"/>
+          <p:cNvPr id="15" name="Text 12"/>
+          <p:cNvSpPr/>
+          <p:nvPr/>
+        </p:nvSpPr>
+        <p:spPr>
+          <a:xfrm>
+            <a:off x="6062472" y="2852928"/>
             <a:ext cx="2468880" cy="365760"/>
           </a:xfrm>
           <a:prstGeom prst="rect">
@@ -7295,7 +6729,7 @@
           <a:bodyPr wrap="square" rtlCol="0" anchor="ctr"/>
           <a:lstStyle/>
           <a:p>
-            <a:pPr indent="0" marL="0">
+            <a:pPr marL="0" indent="0">
               <a:buNone/>
             </a:pPr>
             <a:r>
@@ -7307,7 +6741,7 @@
                 <a:ea typeface="Arial" pitchFamily="34" charset="-122"/>
                 <a:cs typeface="Arial" pitchFamily="34" charset="-120"/>
               </a:rPr>
-              <a:t>Inside a Power-5</a:t>
+              <a:t>Legal &amp; contracting</a:t>
             </a:r>
             <a:endParaRPr lang="en-US" sz="1350" dirty="0"/>
           </a:p>
@@ -7315,13 +6749,13 @@
       </p:sp>
       <p:sp>
         <p:nvSpPr>
-          <p:cNvPr id="24" name="Text 19"/>
-          <p:cNvSpPr/>
-          <p:nvPr/>
-        </p:nvSpPr>
-        <p:spPr>
-          <a:xfrm>
-            <a:off x="6062472" y="5166360"/>
+          <p:cNvPr id="16" name="Text 13"/>
+          <p:cNvSpPr/>
+          <p:nvPr/>
+        </p:nvSpPr>
+        <p:spPr>
+          <a:xfrm>
+            <a:off x="6062472" y="3200400"/>
             <a:ext cx="2414016" cy="640080"/>
           </a:xfrm>
           <a:prstGeom prst="rect">
@@ -7334,7 +6768,7 @@
           <a:bodyPr wrap="square" rtlCol="0" anchor="t"/>
           <a:lstStyle/>
           <a:p>
-            <a:pPr indent="0" marL="0">
+            <a:pPr marL="0" indent="0">
               <a:lnSpc>
                 <a:spcPct val="105000"/>
               </a:lnSpc>
@@ -7349,7 +6783,7 @@
                 <a:ea typeface="Arial" pitchFamily="34" charset="-122"/>
                 <a:cs typeface="Arial" pitchFamily="34" charset="-120"/>
               </a:rPr>
-              <a:t>Associate Director of Development at Arkansas (SEC) — she knows how advancement, donors and ADs actually operate.</a:t>
+              <a:t>A Juris Master in risk management and compliance — she reviews and negotiates contracts, buyouts and NIL deals directly.</a:t>
             </a:r>
             <a:endParaRPr lang="en-US" sz="980" dirty="0"/>
           </a:p>
@@ -7357,13 +6791,13 @@
       </p:sp>
       <p:sp>
         <p:nvSpPr>
-          <p:cNvPr id="25" name="Shape 20"/>
-          <p:cNvSpPr/>
-          <p:nvPr/>
-        </p:nvSpPr>
-        <p:spPr>
-          <a:xfrm>
-            <a:off x="9052560" y="4069080"/>
+          <p:cNvPr id="17" name="Shape 14"/>
+          <p:cNvSpPr/>
+          <p:nvPr/>
+        </p:nvSpPr>
+        <p:spPr>
+          <a:xfrm>
+            <a:off x="9052560" y="2103120"/>
             <a:ext cx="2926080" cy="1783080"/>
           </a:xfrm>
           <a:prstGeom prst="roundRect">
@@ -7379,7 +6813,7 @@
       </p:sp>
       <p:pic>
         <p:nvPicPr>
-          <p:cNvPr id="26" name="Image 3" descr="preencoded.png">    </p:cNvPr>
+          <p:cNvPr id="18" name="Image 1" descr="preencoded.png"/>
           <p:cNvPicPr>
             <a:picLocks noChangeAspect="1"/>
           </p:cNvPicPr>
@@ -7393,7 +6827,7 @@
         </p:blipFill>
         <p:spPr>
           <a:xfrm>
-            <a:off x="9308592" y="4325112"/>
+            <a:off x="9308592" y="2359152"/>
             <a:ext cx="420624" cy="420624"/>
           </a:xfrm>
           <a:prstGeom prst="rect">
@@ -7403,13 +6837,13 @@
       </p:pic>
       <p:sp>
         <p:nvSpPr>
-          <p:cNvPr id="27" name="Text 21"/>
-          <p:cNvSpPr/>
-          <p:nvPr/>
-        </p:nvSpPr>
-        <p:spPr>
-          <a:xfrm>
-            <a:off x="9308592" y="4818888"/>
+          <p:cNvPr id="19" name="Text 15"/>
+          <p:cNvSpPr/>
+          <p:nvPr/>
+        </p:nvSpPr>
+        <p:spPr>
+          <a:xfrm>
+            <a:off x="9308592" y="2852928"/>
             <a:ext cx="2468880" cy="365760"/>
           </a:xfrm>
           <a:prstGeom prst="rect">
@@ -7422,7 +6856,7 @@
           <a:bodyPr wrap="square" rtlCol="0" anchor="ctr"/>
           <a:lstStyle/>
           <a:p>
-            <a:pPr indent="0" marL="0">
+            <a:pPr marL="0" indent="0">
               <a:buNone/>
             </a:pPr>
             <a:r>
@@ -7434,7 +6868,7 @@
                 <a:ea typeface="Arial" pitchFamily="34" charset="-122"/>
                 <a:cs typeface="Arial" pitchFamily="34" charset="-120"/>
               </a:rPr>
-              <a:t>Athlete credibility</a:t>
+              <a:t>Partnerships &amp; gifts</a:t>
             </a:r>
             <a:endParaRPr lang="en-US" sz="1350" dirty="0"/>
           </a:p>
@@ -7442,13 +6876,13 @@
       </p:sp>
       <p:sp>
         <p:nvSpPr>
-          <p:cNvPr id="28" name="Text 22"/>
-          <p:cNvSpPr/>
-          <p:nvPr/>
-        </p:nvSpPr>
-        <p:spPr>
-          <a:xfrm>
-            <a:off x="9308592" y="5166360"/>
+          <p:cNvPr id="20" name="Text 16"/>
+          <p:cNvSpPr/>
+          <p:nvPr/>
+        </p:nvSpPr>
+        <p:spPr>
+          <a:xfrm>
+            <a:off x="9308592" y="3200400"/>
             <a:ext cx="2414016" cy="640080"/>
           </a:xfrm>
           <a:prstGeom prst="rect">
@@ -7461,7 +6895,7 @@
           <a:bodyPr wrap="square" rtlCol="0" anchor="t"/>
           <a:lstStyle/>
           <a:p>
-            <a:pPr indent="0" marL="0">
+            <a:pPr marL="0" indent="0">
               <a:lnSpc>
                 <a:spcPct val="105000"/>
               </a:lnSpc>
@@ -7476,6 +6910,260 @@
                 <a:ea typeface="Arial" pitchFamily="34" charset="-122"/>
                 <a:cs typeface="Arial" pitchFamily="34" charset="-120"/>
               </a:rPr>
+              <a:t>CFRE with 10+ years in major gifts, corporate partnerships and sponsorship — the second revenue line, as a core skill.</a:t>
+            </a:r>
+            <a:endParaRPr lang="en-US" sz="980" dirty="0"/>
+          </a:p>
+        </p:txBody>
+      </p:sp>
+      <p:sp>
+        <p:nvSpPr>
+          <p:cNvPr id="21" name="Shape 17"/>
+          <p:cNvSpPr/>
+          <p:nvPr/>
+        </p:nvSpPr>
+        <p:spPr>
+          <a:xfrm>
+            <a:off x="5806440" y="4069080"/>
+            <a:ext cx="2926080" cy="1783080"/>
+          </a:xfrm>
+          <a:prstGeom prst="roundRect">
+            <a:avLst>
+              <a:gd name="adj" fmla="val 5128"/>
+            </a:avLst>
+          </a:prstGeom>
+          <a:solidFill>
+            <a:srgbClr val="121A2B"/>
+          </a:solidFill>
+          <a:ln/>
+        </p:spPr>
+      </p:sp>
+      <p:pic>
+        <p:nvPicPr>
+          <p:cNvPr id="22" name="Image 2" descr="preencoded.png"/>
+          <p:cNvPicPr>
+            <a:picLocks noChangeAspect="1"/>
+          </p:cNvPicPr>
+          <p:nvPr/>
+        </p:nvPicPr>
+        <p:blipFill>
+          <a:blip r:embed="rId5"/>
+          <a:stretch>
+            <a:fillRect/>
+          </a:stretch>
+        </p:blipFill>
+        <p:spPr>
+          <a:xfrm>
+            <a:off x="6062472" y="4325112"/>
+            <a:ext cx="420624" cy="420624"/>
+          </a:xfrm>
+          <a:prstGeom prst="rect">
+            <a:avLst/>
+          </a:prstGeom>
+        </p:spPr>
+      </p:pic>
+      <p:sp>
+        <p:nvSpPr>
+          <p:cNvPr id="23" name="Text 18"/>
+          <p:cNvSpPr/>
+          <p:nvPr/>
+        </p:nvSpPr>
+        <p:spPr>
+          <a:xfrm>
+            <a:off x="6062472" y="4818888"/>
+            <a:ext cx="2468880" cy="365760"/>
+          </a:xfrm>
+          <a:prstGeom prst="rect">
+            <a:avLst/>
+          </a:prstGeom>
+          <a:noFill/>
+          <a:ln/>
+        </p:spPr>
+        <p:txBody>
+          <a:bodyPr wrap="square" rtlCol="0" anchor="ctr"/>
+          <a:lstStyle/>
+          <a:p>
+            <a:pPr marL="0" indent="0">
+              <a:buNone/>
+            </a:pPr>
+            <a:r>
+              <a:rPr lang="en-US" sz="1350" b="1" dirty="0">
+                <a:solidFill>
+                  <a:srgbClr val="93B4FF"/>
+                </a:solidFill>
+                <a:latin typeface="Arial" pitchFamily="34" charset="0"/>
+                <a:ea typeface="Arial" pitchFamily="34" charset="-122"/>
+                <a:cs typeface="Arial" pitchFamily="34" charset="-120"/>
+              </a:rPr>
+              <a:t>Inside a Power-5</a:t>
+            </a:r>
+            <a:endParaRPr lang="en-US" sz="1350" dirty="0"/>
+          </a:p>
+        </p:txBody>
+      </p:sp>
+      <p:sp>
+        <p:nvSpPr>
+          <p:cNvPr id="24" name="Text 19"/>
+          <p:cNvSpPr/>
+          <p:nvPr/>
+        </p:nvSpPr>
+        <p:spPr>
+          <a:xfrm>
+            <a:off x="6062472" y="5166360"/>
+            <a:ext cx="2414016" cy="640080"/>
+          </a:xfrm>
+          <a:prstGeom prst="rect">
+            <a:avLst/>
+          </a:prstGeom>
+          <a:noFill/>
+          <a:ln/>
+        </p:spPr>
+        <p:txBody>
+          <a:bodyPr wrap="square" rtlCol="0" anchor="t"/>
+          <a:lstStyle/>
+          <a:p>
+            <a:pPr marL="0" indent="0">
+              <a:lnSpc>
+                <a:spcPct val="105000"/>
+              </a:lnSpc>
+              <a:buNone/>
+            </a:pPr>
+            <a:r>
+              <a:rPr lang="en-US" sz="980" dirty="0">
+                <a:solidFill>
+                  <a:srgbClr val="C3CAD6"/>
+                </a:solidFill>
+                <a:latin typeface="Arial" pitchFamily="34" charset="0"/>
+                <a:ea typeface="Arial" pitchFamily="34" charset="-122"/>
+                <a:cs typeface="Arial" pitchFamily="34" charset="-120"/>
+              </a:rPr>
+              <a:t>Associate Director of Development at Arkansas (SEC) — she knows how advancement, donors and ADs actually operate.</a:t>
+            </a:r>
+            <a:endParaRPr lang="en-US" sz="980" dirty="0"/>
+          </a:p>
+        </p:txBody>
+      </p:sp>
+      <p:sp>
+        <p:nvSpPr>
+          <p:cNvPr id="25" name="Shape 20"/>
+          <p:cNvSpPr/>
+          <p:nvPr/>
+        </p:nvSpPr>
+        <p:spPr>
+          <a:xfrm>
+            <a:off x="9052560" y="4069080"/>
+            <a:ext cx="2926080" cy="1783080"/>
+          </a:xfrm>
+          <a:prstGeom prst="roundRect">
+            <a:avLst>
+              <a:gd name="adj" fmla="val 5128"/>
+            </a:avLst>
+          </a:prstGeom>
+          <a:solidFill>
+            <a:srgbClr val="121A2B"/>
+          </a:solidFill>
+          <a:ln/>
+        </p:spPr>
+      </p:sp>
+      <p:pic>
+        <p:nvPicPr>
+          <p:cNvPr id="26" name="Image 3" descr="preencoded.png"/>
+          <p:cNvPicPr>
+            <a:picLocks noChangeAspect="1"/>
+          </p:cNvPicPr>
+          <p:nvPr/>
+        </p:nvPicPr>
+        <p:blipFill>
+          <a:blip r:embed="rId6"/>
+          <a:stretch>
+            <a:fillRect/>
+          </a:stretch>
+        </p:blipFill>
+        <p:spPr>
+          <a:xfrm>
+            <a:off x="9308592" y="4325112"/>
+            <a:ext cx="420624" cy="420624"/>
+          </a:xfrm>
+          <a:prstGeom prst="rect">
+            <a:avLst/>
+          </a:prstGeom>
+        </p:spPr>
+      </p:pic>
+      <p:sp>
+        <p:nvSpPr>
+          <p:cNvPr id="27" name="Text 21"/>
+          <p:cNvSpPr/>
+          <p:nvPr/>
+        </p:nvSpPr>
+        <p:spPr>
+          <a:xfrm>
+            <a:off x="9308592" y="4818888"/>
+            <a:ext cx="2468880" cy="365760"/>
+          </a:xfrm>
+          <a:prstGeom prst="rect">
+            <a:avLst/>
+          </a:prstGeom>
+          <a:noFill/>
+          <a:ln/>
+        </p:spPr>
+        <p:txBody>
+          <a:bodyPr wrap="square" rtlCol="0" anchor="ctr"/>
+          <a:lstStyle/>
+          <a:p>
+            <a:pPr marL="0" indent="0">
+              <a:buNone/>
+            </a:pPr>
+            <a:r>
+              <a:rPr lang="en-US" sz="1350" b="1" dirty="0">
+                <a:solidFill>
+                  <a:srgbClr val="93B4FF"/>
+                </a:solidFill>
+                <a:latin typeface="Arial" pitchFamily="34" charset="0"/>
+                <a:ea typeface="Arial" pitchFamily="34" charset="-122"/>
+                <a:cs typeface="Arial" pitchFamily="34" charset="-120"/>
+              </a:rPr>
+              <a:t>Athlete credibility</a:t>
+            </a:r>
+            <a:endParaRPr lang="en-US" sz="1350" dirty="0"/>
+          </a:p>
+        </p:txBody>
+      </p:sp>
+      <p:sp>
+        <p:nvSpPr>
+          <p:cNvPr id="28" name="Text 22"/>
+          <p:cNvSpPr/>
+          <p:nvPr/>
+        </p:nvSpPr>
+        <p:spPr>
+          <a:xfrm>
+            <a:off x="9308592" y="5166360"/>
+            <a:ext cx="2414016" cy="640080"/>
+          </a:xfrm>
+          <a:prstGeom prst="rect">
+            <a:avLst/>
+          </a:prstGeom>
+          <a:noFill/>
+          <a:ln/>
+        </p:spPr>
+        <p:txBody>
+          <a:bodyPr wrap="square" rtlCol="0" anchor="t"/>
+          <a:lstStyle/>
+          <a:p>
+            <a:pPr marL="0" indent="0">
+              <a:lnSpc>
+                <a:spcPct val="105000"/>
+              </a:lnSpc>
+              <a:buNone/>
+            </a:pPr>
+            <a:r>
+              <a:rPr lang="en-US" sz="980" dirty="0">
+                <a:solidFill>
+                  <a:srgbClr val="C3CAD6"/>
+                </a:solidFill>
+                <a:latin typeface="Arial" pitchFamily="34" charset="0"/>
+                <a:ea typeface="Arial" pitchFamily="34" charset="-122"/>
+                <a:cs typeface="Arial" pitchFamily="34" charset="-120"/>
+              </a:rPr>
               <a:t>A former Howard volleyball student-athlete with a natural HBCU and women's-sports network the giants don't prioritize.</a:t>
             </a:r>
             <a:endParaRPr lang="en-US" sz="980" dirty="0"/>
@@ -7503,7 +7191,7 @@
           <a:bodyPr wrap="square" rtlCol="0" anchor="ctr"/>
           <a:lstStyle/>
           <a:p>
-            <a:pPr indent="0" marL="0">
+            <a:pPr marL="0" indent="0">
               <a:buNone/>
             </a:pPr>
             <a:r>
@@ -7517,9 +7205,6 @@
               </a:rPr>
               <a:t>Dexter Sports Co.</a:t>
             </a:r>
-            <a:pPr indent="0" marL="0">
-              <a:buNone/>
-            </a:pPr>
             <a:r>
               <a:rPr lang="en-US" sz="850" dirty="0">
                 <a:solidFill>
@@ -7551,6 +7236,7 @@
         <a:solidFill>
           <a:srgbClr val="FFFFFF"/>
         </a:solidFill>
+        <a:effectLst/>
       </p:bgPr>
     </p:bg>
     <p:spTree>
@@ -7588,7 +7274,7 @@
           <a:bodyPr wrap="square" rtlCol="0" anchor="ctr"/>
           <a:lstStyle/>
           <a:p>
-            <a:pPr indent="0" marL="0">
+            <a:pPr marL="0" indent="0">
               <a:buNone/>
             </a:pPr>
             <a:r>
@@ -7602,11 +7288,8 @@
               </a:rPr>
               <a:t>● </a:t>
             </a:r>
-            <a:pPr indent="0" marL="0">
-              <a:buNone/>
-            </a:pPr>
-            <a:r>
-              <a:rPr lang="en-US" sz="1100" b="1" spc="300" kern="0" dirty="0">
+            <a:r>
+              <a:rPr lang="en-US" sz="1100" b="1" kern="0" spc="300" dirty="0">
                 <a:solidFill>
                   <a:srgbClr val="2563EB"/>
                 </a:solidFill>
@@ -7641,7 +7324,7 @@
           <a:bodyPr wrap="square" rtlCol="0" anchor="ctr"/>
           <a:lstStyle/>
           <a:p>
-            <a:pPr indent="0" marL="0">
+            <a:pPr marL="0" indent="0">
               <a:buNone/>
             </a:pPr>
             <a:r>
@@ -7655,9 +7338,6 @@
               </a:rPr>
               <a:t>Two specialties. </a:t>
             </a:r>
-            <a:pPr indent="0" marL="0">
-              <a:buNone/>
-            </a:pPr>
             <a:r>
               <a:rPr lang="en-US" sz="2900" i="1" dirty="0">
                 <a:solidFill>
@@ -7694,7 +7374,7 @@
           <a:bodyPr wrap="square" rtlCol="0" anchor="ctr"/>
           <a:lstStyle/>
           <a:p>
-            <a:pPr indent="0" marL="0">
+            <a:pPr marL="0" indent="0">
               <a:buNone/>
             </a:pPr>
             <a:r>
@@ -7758,14 +7438,14 @@
       </p:sp>
       <p:pic>
         <p:nvPicPr>
-          <p:cNvPr id="7" name="Image 0" descr="preencoded.png">    </p:cNvPr>
+          <p:cNvPr id="7" name="Image 0" descr="preencoded.png"/>
           <p:cNvPicPr>
             <a:picLocks noChangeAspect="1"/>
           </p:cNvPicPr>
           <p:nvPr/>
         </p:nvPicPr>
         <p:blipFill>
-          <a:blip r:embed="rId1"/>
+          <a:blip r:embed="rId3"/>
           <a:stretch>
             <a:fillRect/>
           </a:stretch>
@@ -7801,7 +7481,7 @@
           <a:bodyPr wrap="square" rtlCol="0" anchor="ctr"/>
           <a:lstStyle/>
           <a:p>
-            <a:pPr indent="0" marL="0">
+            <a:pPr marL="0" indent="0">
               <a:buNone/>
             </a:pPr>
             <a:r>
@@ -7840,7 +7520,7 @@
           <a:bodyPr wrap="square" rtlCol="0" anchor="t"/>
           <a:lstStyle/>
           <a:p>
-            <a:pPr indent="0" marL="0">
+            <a:pPr marL="0" indent="0">
               <a:lnSpc>
                 <a:spcPct val="112000"/>
               </a:lnSpc>
@@ -7912,14 +7592,14 @@
       </p:sp>
       <p:pic>
         <p:nvPicPr>
-          <p:cNvPr id="12" name="Image 1" descr="preencoded.png">    </p:cNvPr>
+          <p:cNvPr id="12" name="Image 1" descr="preencoded.png"/>
           <p:cNvPicPr>
             <a:picLocks noChangeAspect="1"/>
           </p:cNvPicPr>
           <p:nvPr/>
         </p:nvPicPr>
         <p:blipFill>
-          <a:blip r:embed="rId2"/>
+          <a:blip r:embed="rId4"/>
           <a:stretch>
             <a:fillRect/>
           </a:stretch>
@@ -7955,7 +7635,7 @@
           <a:bodyPr wrap="square" rtlCol="0" anchor="ctr"/>
           <a:lstStyle/>
           <a:p>
-            <a:pPr indent="0" marL="0">
+            <a:pPr marL="0" indent="0">
               <a:buNone/>
             </a:pPr>
             <a:r>
@@ -7994,7 +7674,7 @@
           <a:bodyPr wrap="square" rtlCol="0" anchor="t"/>
           <a:lstStyle/>
           <a:p>
-            <a:pPr indent="0" marL="0">
+            <a:pPr marL="0" indent="0">
               <a:lnSpc>
                 <a:spcPct val="112000"/>
               </a:lnSpc>
@@ -8036,7 +7716,7 @@
           <a:bodyPr wrap="square" rtlCol="0" anchor="ctr"/>
           <a:lstStyle/>
           <a:p>
-            <a:pPr indent="0" marL="0">
+            <a:pPr marL="0" indent="0">
               <a:buNone/>
             </a:pPr>
             <a:r>
@@ -8050,9 +7730,6 @@
               </a:rPr>
               <a:t>Dexter Sports Co.</a:t>
             </a:r>
-            <a:pPr indent="0" marL="0">
-              <a:buNone/>
-            </a:pPr>
             <a:r>
               <a:rPr lang="en-US" sz="850" dirty="0">
                 <a:solidFill>
@@ -8084,6 +7761,7 @@
         <a:solidFill>
           <a:srgbClr val="0B1220"/>
         </a:solidFill>
+        <a:effectLst/>
       </p:bgPr>
     </p:bg>
     <p:spTree>
@@ -8121,7 +7799,7 @@
           <a:bodyPr wrap="square" rtlCol="0" anchor="ctr"/>
           <a:lstStyle/>
           <a:p>
-            <a:pPr indent="0" marL="0">
+            <a:pPr marL="0" indent="0">
               <a:buNone/>
             </a:pPr>
             <a:r>
@@ -8135,11 +7813,8 @@
               </a:rPr>
               <a:t>● </a:t>
             </a:r>
-            <a:pPr indent="0" marL="0">
-              <a:buNone/>
-            </a:pPr>
-            <a:r>
-              <a:rPr lang="en-US" sz="1100" b="1" spc="300" kern="0" dirty="0">
+            <a:r>
+              <a:rPr lang="en-US" sz="1100" b="1" kern="0" spc="300" dirty="0">
                 <a:solidFill>
                   <a:srgbClr val="93B4FF"/>
                 </a:solidFill>
@@ -8174,7 +7849,7 @@
           <a:bodyPr wrap="square" rtlCol="0" anchor="ctr"/>
           <a:lstStyle/>
           <a:p>
-            <a:pPr indent="0" marL="0">
+            <a:pPr marL="0" indent="0">
               <a:buNone/>
             </a:pPr>
             <a:r>
@@ -8188,9 +7863,6 @@
               </a:rPr>
               <a:t>Mission and margin, </a:t>
             </a:r>
-            <a:pPr indent="0" marL="0">
-              <a:buNone/>
-            </a:pPr>
             <a:r>
               <a:rPr lang="en-US" sz="2900" i="1" dirty="0">
                 <a:solidFill>
@@ -8227,7 +7899,7 @@
           <a:bodyPr wrap="square" rtlCol="0" anchor="ctr"/>
           <a:lstStyle/>
           <a:p>
-            <a:pPr indent="0" marL="0">
+            <a:pPr marL="0" indent="0">
               <a:buNone/>
             </a:pPr>
             <a:r>
@@ -8269,261 +7941,7 @@
       </p:sp>
       <p:pic>
         <p:nvPicPr>
-          <p:cNvPr id="6" name="Image 0" descr="preencoded.png">    </p:cNvPr>
-          <p:cNvPicPr>
-            <a:picLocks noChangeAspect="1"/>
-          </p:cNvPicPr>
-          <p:nvPr/>
-        </p:nvPicPr>
-        <p:blipFill>
-          <a:blip r:embed="rId1"/>
-          <a:stretch>
-            <a:fillRect/>
-          </a:stretch>
-        </p:blipFill>
-        <p:spPr>
-          <a:xfrm>
-            <a:off x="1005840" y="2697480"/>
-            <a:ext cx="548640" cy="548640"/>
-          </a:xfrm>
-          <a:prstGeom prst="rect">
-            <a:avLst/>
-          </a:prstGeom>
-        </p:spPr>
-      </p:pic>
-      <p:sp>
-        <p:nvSpPr>
-          <p:cNvPr id="7" name="Text 4"/>
-          <p:cNvSpPr/>
-          <p:nvPr/>
-        </p:nvSpPr>
-        <p:spPr>
-          <a:xfrm>
-            <a:off x="1005840" y="3429000"/>
-            <a:ext cx="1965960" cy="640080"/>
-          </a:xfrm>
-          <a:prstGeom prst="rect">
-            <a:avLst/>
-          </a:prstGeom>
-          <a:noFill/>
-          <a:ln/>
-        </p:spPr>
-        <p:txBody>
-          <a:bodyPr wrap="square" rtlCol="0" anchor="t"/>
-          <a:lstStyle/>
-          <a:p>
-            <a:pPr indent="0" marL="0">
-              <a:buNone/>
-            </a:pPr>
-            <a:r>
-              <a:rPr lang="en-US" sz="1600" b="1" dirty="0">
-                <a:solidFill>
-                  <a:srgbClr val="93B4FF"/>
-                </a:solidFill>
-                <a:latin typeface="Arial" pitchFamily="34" charset="0"/>
-                <a:ea typeface="Arial" pitchFamily="34" charset="-122"/>
-                <a:cs typeface="Arial" pitchFamily="34" charset="-120"/>
-              </a:rPr>
-              <a:t>Women-owned</a:t>
-            </a:r>
-            <a:endParaRPr lang="en-US" sz="1600" dirty="0"/>
-          </a:p>
-        </p:txBody>
-      </p:sp>
-      <p:sp>
-        <p:nvSpPr>
-          <p:cNvPr id="8" name="Text 5"/>
-          <p:cNvSpPr/>
-          <p:nvPr/>
-        </p:nvSpPr>
-        <p:spPr>
-          <a:xfrm>
-            <a:off x="1005840" y="4114800"/>
-            <a:ext cx="1965960" cy="1280160"/>
-          </a:xfrm>
-          <a:prstGeom prst="rect">
-            <a:avLst/>
-          </a:prstGeom>
-          <a:noFill/>
-          <a:ln/>
-        </p:spPr>
-        <p:txBody>
-          <a:bodyPr wrap="square" rtlCol="0" anchor="t"/>
-          <a:lstStyle/>
-          <a:p>
-            <a:pPr indent="0" marL="0">
-              <a:lnSpc>
-                <a:spcPct val="110000"/>
-              </a:lnSpc>
-              <a:buNone/>
-            </a:pPr>
-            <a:r>
-              <a:rPr lang="en-US" sz="1150" dirty="0">
-                <a:solidFill>
-                  <a:srgbClr val="C3CAD6"/>
-                </a:solidFill>
-                <a:latin typeface="Arial" pitchFamily="34" charset="0"/>
-                <a:ea typeface="Arial" pitchFamily="34" charset="-122"/>
-                <a:cs typeface="Arial" pitchFamily="34" charset="-120"/>
-              </a:rPr>
-              <a:t>Founded and led by Kim Dexter — ownership and decisions rest with a woman operator in a male-dominated field.</a:t>
-            </a:r>
-            <a:endParaRPr lang="en-US" sz="1150" dirty="0"/>
-          </a:p>
-        </p:txBody>
-      </p:sp>
-      <p:sp>
-        <p:nvSpPr>
-          <p:cNvPr id="9" name="Shape 6"/>
-          <p:cNvSpPr/>
-          <p:nvPr/>
-        </p:nvSpPr>
-        <p:spPr>
-          <a:xfrm>
-            <a:off x="3529584" y="2331720"/>
-            <a:ext cx="2606040" cy="3200400"/>
-          </a:xfrm>
-          <a:prstGeom prst="roundRect">
-            <a:avLst>
-              <a:gd name="adj" fmla="val 4211"/>
-            </a:avLst>
-          </a:prstGeom>
-          <a:solidFill>
-            <a:srgbClr val="121A2B"/>
-          </a:solidFill>
-          <a:ln/>
-        </p:spPr>
-      </p:sp>
-      <p:pic>
-        <p:nvPicPr>
-          <p:cNvPr id="10" name="Image 1" descr="preencoded.png">    </p:cNvPr>
-          <p:cNvPicPr>
-            <a:picLocks noChangeAspect="1"/>
-          </p:cNvPicPr>
-          <p:nvPr/>
-        </p:nvPicPr>
-        <p:blipFill>
-          <a:blip r:embed="rId2"/>
-          <a:stretch>
-            <a:fillRect/>
-          </a:stretch>
-        </p:blipFill>
-        <p:spPr>
-          <a:xfrm>
-            <a:off x="3849624" y="2697480"/>
-            <a:ext cx="548640" cy="548640"/>
-          </a:xfrm>
-          <a:prstGeom prst="rect">
-            <a:avLst/>
-          </a:prstGeom>
-        </p:spPr>
-      </p:pic>
-      <p:sp>
-        <p:nvSpPr>
-          <p:cNvPr id="11" name="Text 7"/>
-          <p:cNvSpPr/>
-          <p:nvPr/>
-        </p:nvSpPr>
-        <p:spPr>
-          <a:xfrm>
-            <a:off x="3849624" y="3429000"/>
-            <a:ext cx="1965960" cy="640080"/>
-          </a:xfrm>
-          <a:prstGeom prst="rect">
-            <a:avLst/>
-          </a:prstGeom>
-          <a:noFill/>
-          <a:ln/>
-        </p:spPr>
-        <p:txBody>
-          <a:bodyPr wrap="square" rtlCol="0" anchor="t"/>
-          <a:lstStyle/>
-          <a:p>
-            <a:pPr indent="0" marL="0">
-              <a:buNone/>
-            </a:pPr>
-            <a:r>
-              <a:rPr lang="en-US" sz="1600" b="1" dirty="0">
-                <a:solidFill>
-                  <a:srgbClr val="93B4FF"/>
-                </a:solidFill>
-                <a:latin typeface="Arial" pitchFamily="34" charset="0"/>
-                <a:ea typeface="Arial" pitchFamily="34" charset="-122"/>
-                <a:cs typeface="Arial" pitchFamily="34" charset="-120"/>
-              </a:rPr>
-              <a:t>Female-coach outcomes</a:t>
-            </a:r>
-            <a:endParaRPr lang="en-US" sz="1600" dirty="0"/>
-          </a:p>
-        </p:txBody>
-      </p:sp>
-      <p:sp>
-        <p:nvSpPr>
-          <p:cNvPr id="12" name="Text 8"/>
-          <p:cNvSpPr/>
-          <p:nvPr/>
-        </p:nvSpPr>
-        <p:spPr>
-          <a:xfrm>
-            <a:off x="3849624" y="4114800"/>
-            <a:ext cx="1965960" cy="1280160"/>
-          </a:xfrm>
-          <a:prstGeom prst="rect">
-            <a:avLst/>
-          </a:prstGeom>
-          <a:noFill/>
-          <a:ln/>
-        </p:spPr>
-        <p:txBody>
-          <a:bodyPr wrap="square" rtlCol="0" anchor="t"/>
-          <a:lstStyle/>
-          <a:p>
-            <a:pPr indent="0" marL="0">
-              <a:lnSpc>
-                <a:spcPct val="110000"/>
-              </a:lnSpc>
-              <a:buNone/>
-            </a:pPr>
-            <a:r>
-              <a:rPr lang="en-US" sz="1150" dirty="0">
-                <a:solidFill>
-                  <a:srgbClr val="C3CAD6"/>
-                </a:solidFill>
-                <a:latin typeface="Arial" pitchFamily="34" charset="0"/>
-                <a:ea typeface="Arial" pitchFamily="34" charset="-122"/>
-                <a:cs typeface="Arial" pitchFamily="34" charset="-120"/>
-              </a:rPr>
-              <a:t>We prioritize placing and advancing women into higher-paid, higher-visibility roles.</a:t>
-            </a:r>
-            <a:endParaRPr lang="en-US" sz="1150" dirty="0"/>
-          </a:p>
-        </p:txBody>
-      </p:sp>
-      <p:sp>
-        <p:nvSpPr>
-          <p:cNvPr id="13" name="Shape 9"/>
-          <p:cNvSpPr/>
-          <p:nvPr/>
-        </p:nvSpPr>
-        <p:spPr>
-          <a:xfrm>
-            <a:off x="6373368" y="2331720"/>
-            <a:ext cx="2606040" cy="3200400"/>
-          </a:xfrm>
-          <a:prstGeom prst="roundRect">
-            <a:avLst>
-              <a:gd name="adj" fmla="val 4211"/>
-            </a:avLst>
-          </a:prstGeom>
-          <a:solidFill>
-            <a:srgbClr val="121A2B"/>
-          </a:solidFill>
-          <a:ln/>
-        </p:spPr>
-      </p:sp>
-      <p:pic>
-        <p:nvPicPr>
-          <p:cNvPr id="14" name="Image 2" descr="preencoded.png">    </p:cNvPr>
+          <p:cNvPr id="6" name="Image 0" descr="preencoded.png"/>
           <p:cNvPicPr>
             <a:picLocks noChangeAspect="1"/>
           </p:cNvPicPr>
@@ -8537,7 +7955,7 @@
         </p:blipFill>
         <p:spPr>
           <a:xfrm>
-            <a:off x="6693408" y="2697480"/>
+            <a:off x="1005840" y="2697480"/>
             <a:ext cx="548640" cy="548640"/>
           </a:xfrm>
           <a:prstGeom prst="rect">
@@ -8547,13 +7965,13 @@
       </p:pic>
       <p:sp>
         <p:nvSpPr>
-          <p:cNvPr id="15" name="Text 10"/>
-          <p:cNvSpPr/>
-          <p:nvPr/>
-        </p:nvSpPr>
-        <p:spPr>
-          <a:xfrm>
-            <a:off x="6693408" y="3429000"/>
+          <p:cNvPr id="7" name="Text 4"/>
+          <p:cNvSpPr/>
+          <p:nvPr/>
+        </p:nvSpPr>
+        <p:spPr>
+          <a:xfrm>
+            <a:off x="1005840" y="3429000"/>
             <a:ext cx="1965960" cy="640080"/>
           </a:xfrm>
           <a:prstGeom prst="rect">
@@ -8566,7 +7984,7 @@
           <a:bodyPr wrap="square" rtlCol="0" anchor="t"/>
           <a:lstStyle/>
           <a:p>
-            <a:pPr indent="0" marL="0">
+            <a:pPr marL="0" indent="0">
               <a:buNone/>
             </a:pPr>
             <a:r>
@@ -8578,7 +7996,7 @@
                 <a:ea typeface="Arial" pitchFamily="34" charset="-122"/>
                 <a:cs typeface="Arial" pitchFamily="34" charset="-120"/>
               </a:rPr>
-              <a:t>Youth opportunity</a:t>
+              <a:t>Women-owned</a:t>
             </a:r>
             <a:endParaRPr lang="en-US" sz="1600" dirty="0"/>
           </a:p>
@@ -8586,13 +8004,13 @@
       </p:sp>
       <p:sp>
         <p:nvSpPr>
-          <p:cNvPr id="16" name="Text 11"/>
-          <p:cNvSpPr/>
-          <p:nvPr/>
-        </p:nvSpPr>
-        <p:spPr>
-          <a:xfrm>
-            <a:off x="6693408" y="4114800"/>
+          <p:cNvPr id="8" name="Text 5"/>
+          <p:cNvSpPr/>
+          <p:nvPr/>
+        </p:nvSpPr>
+        <p:spPr>
+          <a:xfrm>
+            <a:off x="1005840" y="4114800"/>
             <a:ext cx="1965960" cy="1280160"/>
           </a:xfrm>
           <a:prstGeom prst="rect">
@@ -8605,7 +8023,7 @@
           <a:bodyPr wrap="square" rtlCol="0" anchor="t"/>
           <a:lstStyle/>
           <a:p>
-            <a:pPr indent="0" marL="0">
+            <a:pPr marL="0" indent="0">
               <a:lnSpc>
                 <a:spcPct val="110000"/>
               </a:lnSpc>
@@ -8620,7 +8038,7 @@
                 <a:ea typeface="Arial" pitchFamily="34" charset="-122"/>
                 <a:cs typeface="Arial" pitchFamily="34" charset="-120"/>
               </a:rPr>
-              <a:t>NIL guidance helps Carolina athletes and families — including young women — build value early and equitably.</a:t>
+              <a:t>Founded and led by Kim Dexter — ownership and decisions rest with a woman operator in a male-dominated field.</a:t>
             </a:r>
             <a:endParaRPr lang="en-US" sz="1150" dirty="0"/>
           </a:p>
@@ -8628,13 +8046,13 @@
       </p:sp>
       <p:sp>
         <p:nvSpPr>
-          <p:cNvPr id="17" name="Shape 12"/>
-          <p:cNvSpPr/>
-          <p:nvPr/>
-        </p:nvSpPr>
-        <p:spPr>
-          <a:xfrm>
-            <a:off x="9217152" y="2331720"/>
+          <p:cNvPr id="9" name="Shape 6"/>
+          <p:cNvSpPr/>
+          <p:nvPr/>
+        </p:nvSpPr>
+        <p:spPr>
+          <a:xfrm>
+            <a:off x="3529584" y="2331720"/>
             <a:ext cx="2606040" cy="3200400"/>
           </a:xfrm>
           <a:prstGeom prst="roundRect">
@@ -8650,7 +8068,7 @@
       </p:sp>
       <p:pic>
         <p:nvPicPr>
-          <p:cNvPr id="18" name="Image 3" descr="preencoded.png">    </p:cNvPr>
+          <p:cNvPr id="10" name="Image 1" descr="preencoded.png"/>
           <p:cNvPicPr>
             <a:picLocks noChangeAspect="1"/>
           </p:cNvPicPr>
@@ -8664,7 +8082,7 @@
         </p:blipFill>
         <p:spPr>
           <a:xfrm>
-            <a:off x="9537192" y="2697480"/>
+            <a:off x="3849624" y="2697480"/>
             <a:ext cx="548640" cy="548640"/>
           </a:xfrm>
           <a:prstGeom prst="rect">
@@ -8674,13 +8092,13 @@
       </p:pic>
       <p:sp>
         <p:nvSpPr>
-          <p:cNvPr id="19" name="Text 13"/>
-          <p:cNvSpPr/>
-          <p:nvPr/>
-        </p:nvSpPr>
-        <p:spPr>
-          <a:xfrm>
-            <a:off x="9537192" y="3429000"/>
+          <p:cNvPr id="11" name="Text 7"/>
+          <p:cNvSpPr/>
+          <p:nvPr/>
+        </p:nvSpPr>
+        <p:spPr>
+          <a:xfrm>
+            <a:off x="3849624" y="3429000"/>
             <a:ext cx="1965960" cy="640080"/>
           </a:xfrm>
           <a:prstGeom prst="rect">
@@ -8693,7 +8111,7 @@
           <a:bodyPr wrap="square" rtlCol="0" anchor="t"/>
           <a:lstStyle/>
           <a:p>
-            <a:pPr indent="0" marL="0">
+            <a:pPr marL="0" indent="0">
               <a:buNone/>
             </a:pPr>
             <a:r>
@@ -8705,7 +8123,7 @@
                 <a:ea typeface="Arial" pitchFamily="34" charset="-122"/>
                 <a:cs typeface="Arial" pitchFamily="34" charset="-120"/>
               </a:rPr>
-              <a:t>Aligned economics</a:t>
+              <a:t>Female-coach outcomes</a:t>
             </a:r>
             <a:endParaRPr lang="en-US" sz="1600" dirty="0"/>
           </a:p>
@@ -8713,13 +8131,13 @@
       </p:sp>
       <p:sp>
         <p:nvSpPr>
-          <p:cNvPr id="20" name="Text 14"/>
-          <p:cNvSpPr/>
-          <p:nvPr/>
-        </p:nvSpPr>
-        <p:spPr>
-          <a:xfrm>
-            <a:off x="9537192" y="4114800"/>
+          <p:cNvPr id="12" name="Text 8"/>
+          <p:cNvSpPr/>
+          <p:nvPr/>
+        </p:nvSpPr>
+        <p:spPr>
+          <a:xfrm>
+            <a:off x="3849624" y="4114800"/>
             <a:ext cx="1965960" cy="1280160"/>
           </a:xfrm>
           <a:prstGeom prst="rect">
@@ -8732,7 +8150,7 @@
           <a:bodyPr wrap="square" rtlCol="0" anchor="t"/>
           <a:lstStyle/>
           <a:p>
-            <a:pPr indent="0" marL="0">
+            <a:pPr marL="0" indent="0">
               <a:lnSpc>
                 <a:spcPct val="110000"/>
               </a:lnSpc>
@@ -8747,6 +8165,260 @@
                 <a:ea typeface="Arial" pitchFamily="34" charset="-122"/>
                 <a:cs typeface="Arial" pitchFamily="34" charset="-120"/>
               </a:rPr>
+              <a:t>We prioritize placing and advancing women into higher-paid, higher-visibility roles.</a:t>
+            </a:r>
+            <a:endParaRPr lang="en-US" sz="1150" dirty="0"/>
+          </a:p>
+        </p:txBody>
+      </p:sp>
+      <p:sp>
+        <p:nvSpPr>
+          <p:cNvPr id="13" name="Shape 9"/>
+          <p:cNvSpPr/>
+          <p:nvPr/>
+        </p:nvSpPr>
+        <p:spPr>
+          <a:xfrm>
+            <a:off x="6373368" y="2331720"/>
+            <a:ext cx="2606040" cy="3200400"/>
+          </a:xfrm>
+          <a:prstGeom prst="roundRect">
+            <a:avLst>
+              <a:gd name="adj" fmla="val 4211"/>
+            </a:avLst>
+          </a:prstGeom>
+          <a:solidFill>
+            <a:srgbClr val="121A2B"/>
+          </a:solidFill>
+          <a:ln/>
+        </p:spPr>
+      </p:sp>
+      <p:pic>
+        <p:nvPicPr>
+          <p:cNvPr id="14" name="Image 2" descr="preencoded.png"/>
+          <p:cNvPicPr>
+            <a:picLocks noChangeAspect="1"/>
+          </p:cNvPicPr>
+          <p:nvPr/>
+        </p:nvPicPr>
+        <p:blipFill>
+          <a:blip r:embed="rId5"/>
+          <a:stretch>
+            <a:fillRect/>
+          </a:stretch>
+        </p:blipFill>
+        <p:spPr>
+          <a:xfrm>
+            <a:off x="6693408" y="2697480"/>
+            <a:ext cx="548640" cy="548640"/>
+          </a:xfrm>
+          <a:prstGeom prst="rect">
+            <a:avLst/>
+          </a:prstGeom>
+        </p:spPr>
+      </p:pic>
+      <p:sp>
+        <p:nvSpPr>
+          <p:cNvPr id="15" name="Text 10"/>
+          <p:cNvSpPr/>
+          <p:nvPr/>
+        </p:nvSpPr>
+        <p:spPr>
+          <a:xfrm>
+            <a:off x="6693408" y="3429000"/>
+            <a:ext cx="1965960" cy="640080"/>
+          </a:xfrm>
+          <a:prstGeom prst="rect">
+            <a:avLst/>
+          </a:prstGeom>
+          <a:noFill/>
+          <a:ln/>
+        </p:spPr>
+        <p:txBody>
+          <a:bodyPr wrap="square" rtlCol="0" anchor="t"/>
+          <a:lstStyle/>
+          <a:p>
+            <a:pPr marL="0" indent="0">
+              <a:buNone/>
+            </a:pPr>
+            <a:r>
+              <a:rPr lang="en-US" sz="1600" b="1" dirty="0">
+                <a:solidFill>
+                  <a:srgbClr val="93B4FF"/>
+                </a:solidFill>
+                <a:latin typeface="Arial" pitchFamily="34" charset="0"/>
+                <a:ea typeface="Arial" pitchFamily="34" charset="-122"/>
+                <a:cs typeface="Arial" pitchFamily="34" charset="-120"/>
+              </a:rPr>
+              <a:t>Youth opportunity</a:t>
+            </a:r>
+            <a:endParaRPr lang="en-US" sz="1600" dirty="0"/>
+          </a:p>
+        </p:txBody>
+      </p:sp>
+      <p:sp>
+        <p:nvSpPr>
+          <p:cNvPr id="16" name="Text 11"/>
+          <p:cNvSpPr/>
+          <p:nvPr/>
+        </p:nvSpPr>
+        <p:spPr>
+          <a:xfrm>
+            <a:off x="6693408" y="4114800"/>
+            <a:ext cx="1965960" cy="1280160"/>
+          </a:xfrm>
+          <a:prstGeom prst="rect">
+            <a:avLst/>
+          </a:prstGeom>
+          <a:noFill/>
+          <a:ln/>
+        </p:spPr>
+        <p:txBody>
+          <a:bodyPr wrap="square" rtlCol="0" anchor="t"/>
+          <a:lstStyle/>
+          <a:p>
+            <a:pPr marL="0" indent="0">
+              <a:lnSpc>
+                <a:spcPct val="110000"/>
+              </a:lnSpc>
+              <a:buNone/>
+            </a:pPr>
+            <a:r>
+              <a:rPr lang="en-US" sz="1150" dirty="0">
+                <a:solidFill>
+                  <a:srgbClr val="C3CAD6"/>
+                </a:solidFill>
+                <a:latin typeface="Arial" pitchFamily="34" charset="0"/>
+                <a:ea typeface="Arial" pitchFamily="34" charset="-122"/>
+                <a:cs typeface="Arial" pitchFamily="34" charset="-120"/>
+              </a:rPr>
+              <a:t>NIL guidance helps Carolina athletes and families — including young women — build value early and equitably.</a:t>
+            </a:r>
+            <a:endParaRPr lang="en-US" sz="1150" dirty="0"/>
+          </a:p>
+        </p:txBody>
+      </p:sp>
+      <p:sp>
+        <p:nvSpPr>
+          <p:cNvPr id="17" name="Shape 12"/>
+          <p:cNvSpPr/>
+          <p:nvPr/>
+        </p:nvSpPr>
+        <p:spPr>
+          <a:xfrm>
+            <a:off x="9217152" y="2331720"/>
+            <a:ext cx="2606040" cy="3200400"/>
+          </a:xfrm>
+          <a:prstGeom prst="roundRect">
+            <a:avLst>
+              <a:gd name="adj" fmla="val 4211"/>
+            </a:avLst>
+          </a:prstGeom>
+          <a:solidFill>
+            <a:srgbClr val="121A2B"/>
+          </a:solidFill>
+          <a:ln/>
+        </p:spPr>
+      </p:sp>
+      <p:pic>
+        <p:nvPicPr>
+          <p:cNvPr id="18" name="Image 3" descr="preencoded.png"/>
+          <p:cNvPicPr>
+            <a:picLocks noChangeAspect="1"/>
+          </p:cNvPicPr>
+          <p:nvPr/>
+        </p:nvPicPr>
+        <p:blipFill>
+          <a:blip r:embed="rId6"/>
+          <a:stretch>
+            <a:fillRect/>
+          </a:stretch>
+        </p:blipFill>
+        <p:spPr>
+          <a:xfrm>
+            <a:off x="9537192" y="2697480"/>
+            <a:ext cx="548640" cy="548640"/>
+          </a:xfrm>
+          <a:prstGeom prst="rect">
+            <a:avLst/>
+          </a:prstGeom>
+        </p:spPr>
+      </p:pic>
+      <p:sp>
+        <p:nvSpPr>
+          <p:cNvPr id="19" name="Text 13"/>
+          <p:cNvSpPr/>
+          <p:nvPr/>
+        </p:nvSpPr>
+        <p:spPr>
+          <a:xfrm>
+            <a:off x="9537192" y="3429000"/>
+            <a:ext cx="1965960" cy="640080"/>
+          </a:xfrm>
+          <a:prstGeom prst="rect">
+            <a:avLst/>
+          </a:prstGeom>
+          <a:noFill/>
+          <a:ln/>
+        </p:spPr>
+        <p:txBody>
+          <a:bodyPr wrap="square" rtlCol="0" anchor="t"/>
+          <a:lstStyle/>
+          <a:p>
+            <a:pPr marL="0" indent="0">
+              <a:buNone/>
+            </a:pPr>
+            <a:r>
+              <a:rPr lang="en-US" sz="1600" b="1" dirty="0">
+                <a:solidFill>
+                  <a:srgbClr val="93B4FF"/>
+                </a:solidFill>
+                <a:latin typeface="Arial" pitchFamily="34" charset="0"/>
+                <a:ea typeface="Arial" pitchFamily="34" charset="-122"/>
+                <a:cs typeface="Arial" pitchFamily="34" charset="-120"/>
+              </a:rPr>
+              <a:t>Aligned economics</a:t>
+            </a:r>
+            <a:endParaRPr lang="en-US" sz="1600" dirty="0"/>
+          </a:p>
+        </p:txBody>
+      </p:sp>
+      <p:sp>
+        <p:nvSpPr>
+          <p:cNvPr id="20" name="Text 14"/>
+          <p:cNvSpPr/>
+          <p:nvPr/>
+        </p:nvSpPr>
+        <p:spPr>
+          <a:xfrm>
+            <a:off x="9537192" y="4114800"/>
+            <a:ext cx="1965960" cy="1280160"/>
+          </a:xfrm>
+          <a:prstGeom prst="rect">
+            <a:avLst/>
+          </a:prstGeom>
+          <a:noFill/>
+          <a:ln/>
+        </p:spPr>
+        <p:txBody>
+          <a:bodyPr wrap="square" rtlCol="0" anchor="t"/>
+          <a:lstStyle/>
+          <a:p>
+            <a:pPr marL="0" indent="0">
+              <a:lnSpc>
+                <a:spcPct val="110000"/>
+              </a:lnSpc>
+              <a:buNone/>
+            </a:pPr>
+            <a:r>
+              <a:rPr lang="en-US" sz="1150" dirty="0">
+                <a:solidFill>
+                  <a:srgbClr val="C3CAD6"/>
+                </a:solidFill>
+                <a:latin typeface="Arial" pitchFamily="34" charset="0"/>
+                <a:ea typeface="Arial" pitchFamily="34" charset="-122"/>
+                <a:cs typeface="Arial" pitchFamily="34" charset="-120"/>
+              </a:rPr>
               <a:t>Success-based fees mean we win only when clients win. No conflict between doing well and doing good.</a:t>
             </a:r>
             <a:endParaRPr lang="en-US" sz="1150" dirty="0"/>
@@ -8774,7 +8446,7 @@
           <a:bodyPr wrap="square" rtlCol="0" anchor="ctr"/>
           <a:lstStyle/>
           <a:p>
-            <a:pPr indent="0" marL="0">
+            <a:pPr marL="0" indent="0">
               <a:buNone/>
             </a:pPr>
             <a:r>
@@ -8788,9 +8460,6 @@
               </a:rPr>
               <a:t>Dexter Sports Co.</a:t>
             </a:r>
-            <a:pPr indent="0" marL="0">
-              <a:buNone/>
-            </a:pPr>
             <a:r>
               <a:rPr lang="en-US" sz="850" dirty="0">
                 <a:solidFill>
@@ -9107,4 +8776,319 @@
     </a:ext>
   </a:extLst>
 </a:theme>
+</file>
+
+<file path=ppt/theme/theme2.xml><?xml version="1.0" encoding="utf-8"?>
+<a:theme xmlns:a="http://schemas.openxmlformats.org/drawingml/2006/main" name="Office Theme">
+  <a:themeElements>
+    <a:clrScheme name="Office">
+      <a:dk1>
+        <a:sysClr val="windowText" lastClr="000000"/>
+      </a:dk1>
+      <a:lt1>
+        <a:sysClr val="window" lastClr="FFFFFF"/>
+      </a:lt1>
+      <a:dk2>
+        <a:srgbClr val="0E2841"/>
+      </a:dk2>
+      <a:lt2>
+        <a:srgbClr val="E8E8E8"/>
+      </a:lt2>
+      <a:accent1>
+        <a:srgbClr val="156082"/>
+      </a:accent1>
+      <a:accent2>
+        <a:srgbClr val="E97132"/>
+      </a:accent2>
+      <a:accent3>
+        <a:srgbClr val="196B24"/>
+      </a:accent3>
+      <a:accent4>
+        <a:srgbClr val="0F9ED5"/>
+      </a:accent4>
+      <a:accent5>
+        <a:srgbClr val="A02B93"/>
+      </a:accent5>
+      <a:accent6>
+        <a:srgbClr val="4EA72E"/>
+      </a:accent6>
+      <a:hlink>
+        <a:srgbClr val="467886"/>
+      </a:hlink>
+      <a:folHlink>
+        <a:srgbClr val="96607D"/>
+      </a:folHlink>
+    </a:clrScheme>
+    <a:fontScheme name="Office">
+      <a:majorFont>
+        <a:latin typeface="Aptos Display" panose="02110004020202020204"/>
+        <a:ea typeface=""/>
+        <a:cs typeface=""/>
+        <a:font script="Jpan" typeface="游ゴシック Light"/>
+        <a:font script="Hang" typeface="맑은 고딕"/>
+        <a:font script="Hans" typeface="等线 Light"/>
+        <a:font script="Hant" typeface="新細明體"/>
+        <a:font script="Arab" typeface="Times New Roman"/>
+        <a:font script="Hebr" typeface="Times New Roman"/>
+        <a:font script="Thai" typeface="Angsana New"/>
+        <a:font script="Ethi" typeface="Nyala"/>
+        <a:font script="Beng" typeface="Vrinda"/>
+        <a:font script="Gujr" typeface="Shruti"/>
+        <a:font script="Khmr" typeface="MoolBoran"/>
+        <a:font script="Knda" typeface="Tunga"/>
+        <a:font script="Guru" typeface="Raavi"/>
+        <a:font script="Cans" typeface="Euphemia"/>
+        <a:font script="Cher" typeface="Plantagenet Cherokee"/>
+        <a:font script="Yiii" typeface="Microsoft Yi Baiti"/>
+        <a:font script="Tibt" typeface="Microsoft Himalaya"/>
+        <a:font script="Thaa" typeface="MV Boli"/>
+        <a:font script="Deva" typeface="Mangal"/>
+        <a:font script="Telu" typeface="Gautami"/>
+        <a:font script="Taml" typeface="Latha"/>
+        <a:font script="Syrc" typeface="Estrangelo Edessa"/>
+        <a:font script="Orya" typeface="Kalinga"/>
+        <a:font script="Mlym" typeface="Kartika"/>
+        <a:font script="Laoo" typeface="DokChampa"/>
+        <a:font script="Sinh" typeface="Iskoola Pota"/>
+        <a:font script="Mong" typeface="Mongolian Baiti"/>
+        <a:font script="Viet" typeface="Times New Roman"/>
+        <a:font script="Uigh" typeface="Microsoft Uighur"/>
+        <a:font script="Geor" typeface="Sylfaen"/>
+        <a:font script="Armn" typeface="Arial"/>
+        <a:font script="Bugi" typeface="Leelawadee UI"/>
+        <a:font script="Bopo" typeface="Microsoft JhengHei"/>
+        <a:font script="Java" typeface="Javanese Text"/>
+        <a:font script="Lisu" typeface="Segoe UI"/>
+        <a:font script="Mymr" typeface="Myanmar Text"/>
+        <a:font script="Nkoo" typeface="Ebrima"/>
+        <a:font script="Olck" typeface="Nirmala UI"/>
+        <a:font script="Osma" typeface="Ebrima"/>
+        <a:font script="Phag" typeface="Phagspa"/>
+        <a:font script="Syrn" typeface="Estrangelo Edessa"/>
+        <a:font script="Syrj" typeface="Estrangelo Edessa"/>
+        <a:font script="Syre" typeface="Estrangelo Edessa"/>
+        <a:font script="Sora" typeface="Nirmala UI"/>
+        <a:font script="Tale" typeface="Microsoft Tai Le"/>
+        <a:font script="Talu" typeface="Microsoft New Tai Lue"/>
+        <a:font script="Tfng" typeface="Ebrima"/>
+      </a:majorFont>
+      <a:minorFont>
+        <a:latin typeface="Aptos" panose="02110004020202020204"/>
+        <a:ea typeface=""/>
+        <a:cs typeface=""/>
+        <a:font script="Jpan" typeface="游ゴシック"/>
+        <a:font script="Hang" typeface="맑은 고딕"/>
+        <a:font script="Hans" typeface="等线"/>
+        <a:font script="Hant" typeface="新細明體"/>
+        <a:font script="Arab" typeface="Arial"/>
+        <a:font script="Hebr" typeface="Arial"/>
+        <a:font script="Thai" typeface="Cordia New"/>
+        <a:font script="Ethi" typeface="Nyala"/>
+        <a:font script="Beng" typeface="Vrinda"/>
+        <a:font script="Gujr" typeface="Shruti"/>
+        <a:font script="Khmr" typeface="DaunPenh"/>
+        <a:font script="Knda" typeface="Tunga"/>
+        <a:font script="Guru" typeface="Raavi"/>
+        <a:font script="Cans" typeface="Euphemia"/>
+        <a:font script="Cher" typeface="Plantagenet Cherokee"/>
+        <a:font script="Yiii" typeface="Microsoft Yi Baiti"/>
+        <a:font script="Tibt" typeface="Microsoft Himalaya"/>
+        <a:font script="Thaa" typeface="MV Boli"/>
+        <a:font script="Deva" typeface="Mangal"/>
+        <a:font script="Telu" typeface="Gautami"/>
+        <a:font script="Taml" typeface="Latha"/>
+        <a:font script="Syrc" typeface="Estrangelo Edessa"/>
+        <a:font script="Orya" typeface="Kalinga"/>
+        <a:font script="Mlym" typeface="Kartika"/>
+        <a:font script="Laoo" typeface="DokChampa"/>
+        <a:font script="Sinh" typeface="Iskoola Pota"/>
+        <a:font script="Mong" typeface="Mongolian Baiti"/>
+        <a:font script="Viet" typeface="Arial"/>
+        <a:font script="Uigh" typeface="Microsoft Uighur"/>
+        <a:font script="Geor" typeface="Sylfaen"/>
+        <a:font script="Armn" typeface="Arial"/>
+        <a:font script="Bugi" typeface="Leelawadee UI"/>
+        <a:font script="Bopo" typeface="Microsoft JhengHei"/>
+        <a:font script="Java" typeface="Javanese Text"/>
+        <a:font script="Lisu" typeface="Segoe UI"/>
+        <a:font script="Mymr" typeface="Myanmar Text"/>
+        <a:font script="Nkoo" typeface="Ebrima"/>
+        <a:font script="Olck" typeface="Nirmala UI"/>
+        <a:font script="Osma" typeface="Ebrima"/>
+        <a:font script="Phag" typeface="Phagspa"/>
+        <a:font script="Syrn" typeface="Estrangelo Edessa"/>
+        <a:font script="Syrj" typeface="Estrangelo Edessa"/>
+        <a:font script="Syre" typeface="Estrangelo Edessa"/>
+        <a:font script="Sora" typeface="Nirmala UI"/>
+        <a:font script="Tale" typeface="Microsoft Tai Le"/>
+        <a:font script="Talu" typeface="Microsoft New Tai Lue"/>
+        <a:font script="Tfng" typeface="Ebrima"/>
+      </a:minorFont>
+    </a:fontScheme>
+    <a:fmtScheme name="Office">
+      <a:fillStyleLst>
+        <a:solidFill>
+          <a:schemeClr val="phClr"/>
+        </a:solidFill>
+        <a:gradFill rotWithShape="1">
+          <a:gsLst>
+            <a:gs pos="0">
+              <a:schemeClr val="phClr">
+                <a:lumMod val="110000"/>
+                <a:satMod val="105000"/>
+                <a:tint val="67000"/>
+              </a:schemeClr>
+            </a:gs>
+            <a:gs pos="50000">
+              <a:schemeClr val="phClr">
+                <a:lumMod val="105000"/>
+                <a:satMod val="103000"/>
+                <a:tint val="73000"/>
+              </a:schemeClr>
+            </a:gs>
+            <a:gs pos="100000">
+              <a:schemeClr val="phClr">
+                <a:lumMod val="105000"/>
+                <a:satMod val="109000"/>
+                <a:tint val="81000"/>
+              </a:schemeClr>
+            </a:gs>
+          </a:gsLst>
+          <a:lin ang="5400000" scaled="0"/>
+        </a:gradFill>
+        <a:gradFill rotWithShape="1">
+          <a:gsLst>
+            <a:gs pos="0">
+              <a:schemeClr val="phClr">
+                <a:satMod val="103000"/>
+                <a:lumMod val="102000"/>
+                <a:tint val="94000"/>
+              </a:schemeClr>
+            </a:gs>
+            <a:gs pos="50000">
+              <a:schemeClr val="phClr">
+                <a:satMod val="110000"/>
+                <a:lumMod val="100000"/>
+                <a:shade val="100000"/>
+              </a:schemeClr>
+            </a:gs>
+            <a:gs pos="100000">
+              <a:schemeClr val="phClr">
+                <a:lumMod val="99000"/>
+                <a:satMod val="120000"/>
+                <a:shade val="78000"/>
+              </a:schemeClr>
+            </a:gs>
+          </a:gsLst>
+          <a:lin ang="5400000" scaled="0"/>
+        </a:gradFill>
+      </a:fillStyleLst>
+      <a:lnStyleLst>
+        <a:ln w="12700" cap="flat" cmpd="sng" algn="ctr">
+          <a:solidFill>
+            <a:schemeClr val="phClr"/>
+          </a:solidFill>
+          <a:prstDash val="solid"/>
+          <a:miter lim="800000"/>
+        </a:ln>
+        <a:ln w="19050" cap="flat" cmpd="sng" algn="ctr">
+          <a:solidFill>
+            <a:schemeClr val="phClr"/>
+          </a:solidFill>
+          <a:prstDash val="solid"/>
+          <a:miter lim="800000"/>
+        </a:ln>
+        <a:ln w="25400" cap="flat" cmpd="sng" algn="ctr">
+          <a:solidFill>
+            <a:schemeClr val="phClr"/>
+          </a:solidFill>
+          <a:prstDash val="solid"/>
+          <a:miter lim="800000"/>
+        </a:ln>
+      </a:lnStyleLst>
+      <a:effectStyleLst>
+        <a:effectStyle>
+          <a:effectLst/>
+        </a:effectStyle>
+        <a:effectStyle>
+          <a:effectLst/>
+        </a:effectStyle>
+        <a:effectStyle>
+          <a:effectLst>
+            <a:outerShdw blurRad="57150" dist="19050" dir="5400000" algn="ctr" rotWithShape="0">
+              <a:srgbClr val="000000">
+                <a:alpha val="63000"/>
+              </a:srgbClr>
+            </a:outerShdw>
+          </a:effectLst>
+        </a:effectStyle>
+      </a:effectStyleLst>
+      <a:bgFillStyleLst>
+        <a:solidFill>
+          <a:schemeClr val="phClr"/>
+        </a:solidFill>
+        <a:solidFill>
+          <a:schemeClr val="phClr">
+            <a:tint val="95000"/>
+            <a:satMod val="170000"/>
+          </a:schemeClr>
+        </a:solidFill>
+        <a:gradFill rotWithShape="1">
+          <a:gsLst>
+            <a:gs pos="0">
+              <a:schemeClr val="phClr">
+                <a:tint val="93000"/>
+                <a:satMod val="150000"/>
+                <a:shade val="98000"/>
+                <a:lumMod val="102000"/>
+              </a:schemeClr>
+            </a:gs>
+            <a:gs pos="50000">
+              <a:schemeClr val="phClr">
+                <a:tint val="98000"/>
+                <a:satMod val="130000"/>
+                <a:shade val="90000"/>
+                <a:lumMod val="103000"/>
+              </a:schemeClr>
+            </a:gs>
+            <a:gs pos="100000">
+              <a:schemeClr val="phClr">
+                <a:shade val="63000"/>
+                <a:satMod val="120000"/>
+              </a:schemeClr>
+            </a:gs>
+          </a:gsLst>
+          <a:lin ang="5400000" scaled="0"/>
+        </a:gradFill>
+      </a:bgFillStyleLst>
+    </a:fmtScheme>
+  </a:themeElements>
+  <a:objectDefaults>
+    <a:lnDef>
+      <a:spPr/>
+      <a:bodyPr/>
+      <a:lstStyle/>
+      <a:style>
+        <a:lnRef idx="2">
+          <a:schemeClr val="accent1"/>
+        </a:lnRef>
+        <a:fillRef idx="0">
+          <a:schemeClr val="accent1"/>
+        </a:fillRef>
+        <a:effectRef idx="1">
+          <a:schemeClr val="accent1"/>
+        </a:effectRef>
+        <a:fontRef idx="minor">
+          <a:schemeClr val="tx1"/>
+        </a:fontRef>
+      </a:style>
+    </a:lnDef>
+  </a:objectDefaults>
+  <a:extraClrSchemeLst/>
+  <a:extLst>
+    <a:ext uri="{05A4C25C-085E-4340-85A3-A5531E510DB2}">
+      <thm15:themeFamily xmlns:thm15="http://schemas.microsoft.com/office/thememl/2012/main" name="Office Theme" id="{2E142A2C-CD16-42D6-873A-C26D2A0506FA}" vid="{1BDDFF52-6CD6-40A5-AB3C-68EB2F1E4D0A}"/>
+    </a:ext>
+  </a:extLst>
+</a:theme>
 </file>
</xml_diff>